<commit_message>
FIM V6 — Charte SHY-Performance · Donateurs français · UNICEF France/Monde
- Entête SHY-Performance sur chaque slide (logo + trait rouge)
- Suppression totale des références UM6, Maroc, Loi 75-00, DH
- Données conservées : UNICEF France/Monde uniquement (€, stats France)
- Slides adressées aux apprenants (vous/votre, impératif, 1ère personne)
- Méthodes pédagogiques appliquées mais non affichées (Bloom, Kolb, Kirkpatrick invisibles)
- Charte couleurs : Teal #008080 / Rouge #FF0000 / Blanc

https://claude.ai/code/session_01KeQ88BfXySEzARHjHzWvmX
</commit_message>
<xml_diff>
--- a/FIM_BookJ1_Fondations_Mission_V6-01062026SHY-TE.pptx
+++ b/FIM_BookJ1_Fondations_Mission_V6-01062026SHY-TE.pptx
@@ -8,6 +8,7 @@
     <p:sldId id="256" r:id="rId7"/>
     <p:sldId id="257" r:id="rId8"/>
     <p:sldId id="258" r:id="rId9"/>
+    <p:sldId id="259" r:id="rId10"/>
   </p:sldIdLst>
   <p:sldSz cx="12188952" cy="6858000" type="screen4x3"/>
   <p:notesSz cx="6858000" cy="9144000"/>
@@ -3142,13 +3143,13 @@
         <p:spPr>
           <a:xfrm>
             <a:off x="0" y="0"/>
-            <a:ext cx="12188952" cy="2377440"/>
+            <a:ext cx="12188952" cy="2286000"/>
           </a:xfrm>
           <a:prstGeom prst="rect">
             <a:avLst/>
           </a:prstGeom>
           <a:solidFill>
-            <a:srgbClr val="005050"/>
+            <a:srgbClr val="005555"/>
           </a:solidFill>
           <a:ln>
             <a:noFill/>
@@ -3184,14 +3185,14 @@
         </p:nvSpPr>
         <p:spPr>
           <a:xfrm>
-            <a:off x="0" y="2331720"/>
-            <a:ext cx="12188952" cy="91440"/>
+            <a:off x="0" y="2267712"/>
+            <a:ext cx="12188952" cy="73152"/>
           </a:xfrm>
           <a:prstGeom prst="rect">
             <a:avLst/>
           </a:prstGeom>
           <a:solidFill>
-            <a:srgbClr val="C9A84C"/>
+            <a:srgbClr val="FF0000"/>
           </a:solidFill>
           <a:ln>
             <a:noFill/>
@@ -3221,14 +3222,57 @@
       </p:sp>
       <p:sp>
         <p:nvSpPr>
-          <p:cNvPr id="5" name="TextBox 4"/>
+          <p:cNvPr id="5" name="Rectangle 4"/>
+          <p:cNvSpPr/>
+          <p:nvPr/>
+        </p:nvSpPr>
+        <p:spPr>
+          <a:xfrm>
+            <a:off x="274320" y="109728"/>
+            <a:ext cx="2926080" cy="822960"/>
+          </a:xfrm>
+          <a:prstGeom prst="rect">
+            <a:avLst/>
+          </a:prstGeom>
+          <a:solidFill>
+            <a:srgbClr val="008080"/>
+          </a:solidFill>
+          <a:ln>
+            <a:noFill/>
+          </a:ln>
+        </p:spPr>
+        <p:style>
+          <a:lnRef idx="1">
+            <a:schemeClr val="accent1"/>
+          </a:lnRef>
+          <a:fillRef idx="3">
+            <a:schemeClr val="accent1"/>
+          </a:fillRef>
+          <a:effectRef idx="2">
+            <a:schemeClr val="accent1"/>
+          </a:effectRef>
+          <a:fontRef idx="minor">
+            <a:schemeClr val="lt1"/>
+          </a:fontRef>
+        </p:style>
+        <p:txBody>
+          <a:bodyPr rtlCol="0" anchor="ctr"/>
+          <a:lstStyle/>
+          <a:p>
+            <a:pPr algn="ctr"/>
+          </a:p>
+        </p:txBody>
+      </p:sp>
+      <p:sp>
+        <p:nvSpPr>
+          <p:cNvPr id="6" name="TextBox 5"/>
           <p:cNvSpPr txBox="1"/>
           <p:nvPr/>
         </p:nvSpPr>
         <p:spPr>
           <a:xfrm>
-            <a:off x="365760" y="182880"/>
-            <a:ext cx="3657600" cy="365760"/>
+            <a:off x="320040" y="118872"/>
+            <a:ext cx="1097280" cy="804672"/>
           </a:xfrm>
           <a:prstGeom prst="rect">
             <a:avLst/>
@@ -3243,26 +3287,137 @@
           <a:p>
             <a:pPr algn="l"/>
             <a:r>
-              <a:rPr sz="1000" b="1" i="0">
+              <a:rPr sz="3600" b="1" i="0">
                 <a:solidFill>
-                  <a:srgbClr val="C9A84C"/>
+                  <a:srgbClr val="FFFFFF"/>
                 </a:solidFill>
               </a:rPr>
-              <a:t>BOOK J1 · Journée 1</a:t>
-            </a:r>
-          </a:p>
-        </p:txBody>
-      </p:sp>
-      <p:sp>
-        <p:nvSpPr>
-          <p:cNvPr id="6" name="TextBox 5"/>
+              <a:t>SHY</a:t>
+            </a:r>
+          </a:p>
+        </p:txBody>
+      </p:sp>
+      <p:sp>
+        <p:nvSpPr>
+          <p:cNvPr id="7" name="TextBox 6"/>
           <p:cNvSpPr txBox="1"/>
           <p:nvPr/>
         </p:nvSpPr>
         <p:spPr>
           <a:xfrm>
-            <a:off x="457200" y="502920"/>
-            <a:ext cx="11247120" cy="1371600"/>
+            <a:off x="1371600" y="347472"/>
+            <a:ext cx="1828800" cy="411480"/>
+          </a:xfrm>
+          <a:prstGeom prst="rect">
+            <a:avLst/>
+          </a:prstGeom>
+          <a:noFill/>
+        </p:spPr>
+        <p:txBody>
+          <a:bodyPr wrap="square">
+            <a:spAutoFit/>
+          </a:bodyPr>
+          <a:lstStyle/>
+          <a:p>
+            <a:pPr algn="l"/>
+            <a:r>
+              <a:rPr sz="1400" b="1" i="0">
+                <a:solidFill>
+                  <a:srgbClr val="FFFFFF"/>
+                </a:solidFill>
+              </a:rPr>
+              <a:t>Performance</a:t>
+            </a:r>
+          </a:p>
+        </p:txBody>
+      </p:sp>
+      <p:sp>
+        <p:nvSpPr>
+          <p:cNvPr id="8" name="Rectangle 7"/>
+          <p:cNvSpPr/>
+          <p:nvPr/>
+        </p:nvSpPr>
+        <p:spPr>
+          <a:xfrm>
+            <a:off x="3337560" y="164592"/>
+            <a:ext cx="36576" cy="658368"/>
+          </a:xfrm>
+          <a:prstGeom prst="rect">
+            <a:avLst/>
+          </a:prstGeom>
+          <a:solidFill>
+            <a:srgbClr val="FF0000"/>
+          </a:solidFill>
+          <a:ln>
+            <a:noFill/>
+          </a:ln>
+        </p:spPr>
+        <p:style>
+          <a:lnRef idx="1">
+            <a:schemeClr val="accent1"/>
+          </a:lnRef>
+          <a:fillRef idx="3">
+            <a:schemeClr val="accent1"/>
+          </a:fillRef>
+          <a:effectRef idx="2">
+            <a:schemeClr val="accent1"/>
+          </a:effectRef>
+          <a:fontRef idx="minor">
+            <a:schemeClr val="lt1"/>
+          </a:fontRef>
+        </p:style>
+        <p:txBody>
+          <a:bodyPr rtlCol="0" anchor="ctr"/>
+          <a:lstStyle/>
+          <a:p>
+            <a:pPr algn="ctr"/>
+          </a:p>
+        </p:txBody>
+      </p:sp>
+      <p:sp>
+        <p:nvSpPr>
+          <p:cNvPr id="9" name="TextBox 8"/>
+          <p:cNvSpPr txBox="1"/>
+          <p:nvPr/>
+        </p:nvSpPr>
+        <p:spPr>
+          <a:xfrm>
+            <a:off x="3474720" y="164592"/>
+            <a:ext cx="8503920" cy="347472"/>
+          </a:xfrm>
+          <a:prstGeom prst="rect">
+            <a:avLst/>
+          </a:prstGeom>
+          <a:noFill/>
+        </p:spPr>
+        <p:txBody>
+          <a:bodyPr wrap="square">
+            <a:spAutoFit/>
+          </a:bodyPr>
+          <a:lstStyle/>
+          <a:p>
+            <a:pPr algn="l"/>
+            <a:r>
+              <a:rPr sz="900" b="1" i="0">
+                <a:solidFill>
+                  <a:srgbClr val="BBEEEE"/>
+                </a:solidFill>
+              </a:rPr>
+              <a:t>BOOK J1  ·  Journée 1  ·  Identité &amp; Valeurs</a:t>
+            </a:r>
+          </a:p>
+        </p:txBody>
+      </p:sp>
+      <p:sp>
+        <p:nvSpPr>
+          <p:cNvPr id="10" name="TextBox 9"/>
+          <p:cNvSpPr txBox="1"/>
+          <p:nvPr/>
+        </p:nvSpPr>
+        <p:spPr>
+          <a:xfrm>
+            <a:off x="320040" y="960120"/>
+            <a:ext cx="11521440" cy="1143000"/>
           </a:xfrm>
           <a:prstGeom prst="rect">
             <a:avLst/>
@@ -3289,14 +3444,14 @@
       </p:sp>
       <p:sp>
         <p:nvSpPr>
-          <p:cNvPr id="7" name="TextBox 6"/>
+          <p:cNvPr id="11" name="TextBox 10"/>
           <p:cNvSpPr txBox="1"/>
           <p:nvPr/>
         </p:nvSpPr>
         <p:spPr>
           <a:xfrm>
-            <a:off x="457200" y="1828800"/>
-            <a:ext cx="11247120" cy="502920"/>
+            <a:off x="320040" y="1920240"/>
+            <a:ext cx="11521440" cy="347472"/>
           </a:xfrm>
           <a:prstGeom prst="rect">
             <a:avLst/>
@@ -3311,26 +3466,69 @@
           <a:p>
             <a:pPr algn="l"/>
             <a:r>
-              <a:rPr sz="1300" b="0" i="1">
+              <a:rPr sz="1200" b="0" i="1">
                 <a:solidFill>
-                  <a:srgbClr val="DDEEEE"/>
+                  <a:srgbClr val="CCEEEE"/>
                 </a:solidFill>
               </a:rPr>
-              <a:t>Ancrage identitaire du fundraiser · Valeurs · Posture · Raison d'agir</a:t>
-            </a:r>
-          </a:p>
-        </p:txBody>
-      </p:sp>
-      <p:sp>
-        <p:nvSpPr>
-          <p:cNvPr id="8" name="TextBox 7"/>
-          <p:cNvSpPr txBox="1"/>
+              <a:t>Qui êtes-vous ? Pourquoi êtes-vous là ? Quelle est votre mission ?</a:t>
+            </a:r>
+          </a:p>
+        </p:txBody>
+      </p:sp>
+      <p:sp>
+        <p:nvSpPr>
+          <p:cNvPr id="12" name="Rectangle 11"/>
+          <p:cNvSpPr/>
           <p:nvPr/>
         </p:nvSpPr>
         <p:spPr>
           <a:xfrm>
             <a:off x="0" y="6492240"/>
             <a:ext cx="12188952" cy="365760"/>
+          </a:xfrm>
+          <a:prstGeom prst="rect">
+            <a:avLst/>
+          </a:prstGeom>
+          <a:solidFill>
+            <a:srgbClr val="005555"/>
+          </a:solidFill>
+          <a:ln>
+            <a:noFill/>
+          </a:ln>
+        </p:spPr>
+        <p:style>
+          <a:lnRef idx="1">
+            <a:schemeClr val="accent1"/>
+          </a:lnRef>
+          <a:fillRef idx="3">
+            <a:schemeClr val="accent1"/>
+          </a:fillRef>
+          <a:effectRef idx="2">
+            <a:schemeClr val="accent1"/>
+          </a:effectRef>
+          <a:fontRef idx="minor">
+            <a:schemeClr val="lt1"/>
+          </a:fontRef>
+        </p:style>
+        <p:txBody>
+          <a:bodyPr rtlCol="0" anchor="ctr"/>
+          <a:lstStyle/>
+          <a:p>
+            <a:pPr algn="ctr"/>
+          </a:p>
+        </p:txBody>
+      </p:sp>
+      <p:sp>
+        <p:nvSpPr>
+          <p:cNvPr id="13" name="TextBox 12"/>
+          <p:cNvSpPr txBox="1"/>
+          <p:nvPr/>
+        </p:nvSpPr>
+        <p:spPr>
+          <a:xfrm>
+            <a:off x="0" y="6519672"/>
+            <a:ext cx="12188952" cy="274320"/>
           </a:xfrm>
           <a:prstGeom prst="rect">
             <a:avLst/>
@@ -3347,10 +3545,46 @@
             <a:r>
               <a:rPr sz="900" b="0" i="0">
                 <a:solidFill>
-                  <a:srgbClr val="888888"/>
+                  <a:srgbClr val="FFFFFF"/>
                 </a:solidFill>
               </a:rPr>
-              <a:t>SHY-Performance · V6-01062026SHY-TE · Référentiel UM6P/CMC 2025</a:t>
+              <a:t>SHY-Performance  ·  Formation FIM  ·  V6-01062026SHY-TE</a:t>
+            </a:r>
+          </a:p>
+        </p:txBody>
+      </p:sp>
+      <p:sp>
+        <p:nvSpPr>
+          <p:cNvPr id="14" name="TextBox 13"/>
+          <p:cNvSpPr txBox="1"/>
+          <p:nvPr/>
+        </p:nvSpPr>
+        <p:spPr>
+          <a:xfrm>
+            <a:off x="457200" y="2514600"/>
+            <a:ext cx="11247120" cy="1097280"/>
+          </a:xfrm>
+          <a:prstGeom prst="rect">
+            <a:avLst/>
+          </a:prstGeom>
+          <a:noFill/>
+        </p:spPr>
+        <p:txBody>
+          <a:bodyPr wrap="square">
+            <a:spAutoFit/>
+          </a:bodyPr>
+          <a:lstStyle/>
+          <a:p>
+            <a:pPr algn="l"/>
+            <a:r>
+              <a:rPr sz="1400" b="0" i="0">
+                <a:solidFill>
+                  <a:srgbClr val="1A1A1A"/>
+                </a:solidFill>
+              </a:rPr>
+              <a:t>Aujourd'hui, vous allez ancrer votre identité de fundraiser.
+Vous comprendrez la cause que vous défendez, les valeurs qui vous guident
+et la posture qui fait toute la différence sur le terrain.</a:t>
             </a:r>
           </a:p>
         </p:txBody>
@@ -3425,13 +3659,13 @@
         <p:spPr>
           <a:xfrm>
             <a:off x="0" y="0"/>
-            <a:ext cx="12188952" cy="685800"/>
+            <a:ext cx="12188952" cy="658368"/>
           </a:xfrm>
           <a:prstGeom prst="rect">
             <a:avLst/>
           </a:prstGeom>
           <a:solidFill>
-            <a:srgbClr val="005050"/>
+            <a:srgbClr val="005555"/>
           </a:solidFill>
           <a:ln>
             <a:noFill/>
@@ -3467,14 +3701,14 @@
         </p:nvSpPr>
         <p:spPr>
           <a:xfrm>
-            <a:off x="0" y="667512"/>
-            <a:ext cx="12188952" cy="36576"/>
+            <a:off x="0" y="640080"/>
+            <a:ext cx="12188952" cy="54864"/>
           </a:xfrm>
           <a:prstGeom prst="rect">
             <a:avLst/>
           </a:prstGeom>
           <a:solidFill>
-            <a:srgbClr val="C9A84C"/>
+            <a:srgbClr val="FF0000"/>
           </a:solidFill>
           <a:ln>
             <a:noFill/>
@@ -3510,8 +3744,8 @@
         </p:nvSpPr>
         <p:spPr>
           <a:xfrm>
-            <a:off x="274320" y="73152"/>
-            <a:ext cx="11612880" cy="566928"/>
+            <a:off x="164592" y="64008"/>
+            <a:ext cx="685800" cy="530352"/>
           </a:xfrm>
           <a:prstGeom prst="rect">
             <a:avLst/>
@@ -3526,66 +3760,32 @@
           <a:p>
             <a:pPr algn="l"/>
             <a:r>
-              <a:rPr sz="1800" b="1" i="0">
+              <a:rPr sz="2000" b="1" i="0">
                 <a:solidFill>
                   <a:srgbClr val="FFFFFF"/>
                 </a:solidFill>
               </a:rPr>
-              <a:t>Objectifs &amp; Séquence Kolb — Journée 1</a:t>
-            </a:r>
-          </a:p>
-        </p:txBody>
-      </p:sp>
-      <p:sp>
-        <p:nvSpPr>
-          <p:cNvPr id="6" name="TextBox 5"/>
-          <p:cNvSpPr txBox="1"/>
-          <p:nvPr/>
-        </p:nvSpPr>
-        <p:spPr>
-          <a:xfrm>
-            <a:off x="0" y="6492240"/>
-            <a:ext cx="12188952" cy="365760"/>
-          </a:xfrm>
-          <a:prstGeom prst="rect">
-            <a:avLst/>
-          </a:prstGeom>
-          <a:noFill/>
-        </p:spPr>
-        <p:txBody>
-          <a:bodyPr wrap="square">
-            <a:spAutoFit/>
-          </a:bodyPr>
-          <a:lstStyle/>
-          <a:p>
-            <a:pPr algn="ctr"/>
-            <a:r>
-              <a:rPr sz="800" b="0" i="0">
-                <a:solidFill>
-                  <a:srgbClr val="888888"/>
-                </a:solidFill>
-              </a:rPr>
-              <a:t>SHY-Performance · V6-01062026SHY-TE</a:t>
-            </a:r>
-          </a:p>
-        </p:txBody>
-      </p:sp>
-      <p:sp>
-        <p:nvSpPr>
-          <p:cNvPr id="7" name="Rectangle 6"/>
+              <a:t>SHY</a:t>
+            </a:r>
+          </a:p>
+        </p:txBody>
+      </p:sp>
+      <p:sp>
+        <p:nvSpPr>
+          <p:cNvPr id="6" name="Rectangle 5"/>
           <p:cNvSpPr/>
           <p:nvPr/>
         </p:nvSpPr>
         <p:spPr>
           <a:xfrm>
-            <a:off x="274320" y="868680"/>
-            <a:ext cx="5486400" cy="347472"/>
+            <a:off x="914400" y="91440"/>
+            <a:ext cx="36576" cy="475488"/>
           </a:xfrm>
           <a:prstGeom prst="rect">
             <a:avLst/>
           </a:prstGeom>
           <a:solidFill>
-            <a:srgbClr val="007A7A"/>
+            <a:srgbClr val="FF0000"/>
           </a:solidFill>
           <a:ln>
             <a:noFill/>
@@ -3615,14 +3815,14 @@
       </p:sp>
       <p:sp>
         <p:nvSpPr>
-          <p:cNvPr id="8" name="TextBox 7"/>
+          <p:cNvPr id="7" name="TextBox 6"/>
           <p:cNvSpPr txBox="1"/>
           <p:nvPr/>
         </p:nvSpPr>
         <p:spPr>
           <a:xfrm>
-            <a:off x="365760" y="905256"/>
-            <a:ext cx="5303520" cy="292608"/>
+            <a:off x="1024128" y="91440"/>
+            <a:ext cx="10881360" cy="475488"/>
           </a:xfrm>
           <a:prstGeom prst="rect">
             <a:avLst/>
@@ -3637,32 +3837,32 @@
           <a:p>
             <a:pPr algn="l"/>
             <a:r>
-              <a:rPr sz="1200" b="1" i="0">
+              <a:rPr sz="1700" b="1" i="0">
                 <a:solidFill>
                   <a:srgbClr val="FFFFFF"/>
                 </a:solidFill>
               </a:rPr>
-              <a:t>Objectifs V6 — Bloom Niv. 1–3</a:t>
-            </a:r>
-          </a:p>
-        </p:txBody>
-      </p:sp>
-      <p:sp>
-        <p:nvSpPr>
-          <p:cNvPr id="9" name="Rectangle 8"/>
+              <a:t>Journée 1 — Ce que vous allez vivre aujourd'hui</a:t>
+            </a:r>
+          </a:p>
+        </p:txBody>
+      </p:sp>
+      <p:sp>
+        <p:nvSpPr>
+          <p:cNvPr id="8" name="Rectangle 7"/>
           <p:cNvSpPr/>
           <p:nvPr/>
         </p:nvSpPr>
         <p:spPr>
           <a:xfrm>
-            <a:off x="6126480" y="868680"/>
-            <a:ext cx="5486400" cy="347472"/>
+            <a:off x="0" y="6492240"/>
+            <a:ext cx="12188952" cy="365760"/>
           </a:xfrm>
           <a:prstGeom prst="rect">
             <a:avLst/>
           </a:prstGeom>
           <a:solidFill>
-            <a:srgbClr val="007A7A"/>
+            <a:srgbClr val="005555"/>
           </a:solidFill>
           <a:ln>
             <a:noFill/>
@@ -3692,14 +3892,14 @@
       </p:sp>
       <p:sp>
         <p:nvSpPr>
-          <p:cNvPr id="10" name="TextBox 9"/>
+          <p:cNvPr id="9" name="TextBox 8"/>
           <p:cNvSpPr txBox="1"/>
           <p:nvPr/>
         </p:nvSpPr>
         <p:spPr>
           <a:xfrm>
-            <a:off x="6217920" y="905256"/>
-            <a:ext cx="5303520" cy="292608"/>
+            <a:off x="0" y="6519672"/>
+            <a:ext cx="12188952" cy="274320"/>
           </a:xfrm>
           <a:prstGeom prst="rect">
             <a:avLst/>
@@ -3712,306 +3912,34 @@
           </a:bodyPr>
           <a:lstStyle/>
           <a:p>
-            <a:pPr algn="l"/>
-            <a:r>
-              <a:rPr sz="1200" b="1" i="0">
+            <a:pPr algn="ctr"/>
+            <a:r>
+              <a:rPr sz="900" b="0" i="0">
                 <a:solidFill>
                   <a:srgbClr val="FFFFFF"/>
                 </a:solidFill>
               </a:rPr>
-              <a:t>Contenu clé</a:t>
-            </a:r>
-          </a:p>
-        </p:txBody>
-      </p:sp>
-      <p:sp>
-        <p:nvSpPr>
-          <p:cNvPr id="11" name="TextBox 10"/>
-          <p:cNvSpPr txBox="1"/>
-          <p:nvPr/>
-        </p:nvSpPr>
-        <p:spPr>
-          <a:xfrm>
-            <a:off x="365760" y="1280160"/>
-            <a:ext cx="5303520" cy="347472"/>
-          </a:xfrm>
-          <a:prstGeom prst="rect">
-            <a:avLst/>
-          </a:prstGeom>
-          <a:noFill/>
-        </p:spPr>
-        <p:txBody>
-          <a:bodyPr wrap="square">
-            <a:spAutoFit/>
-          </a:bodyPr>
-          <a:lstStyle/>
-          <a:p>
-            <a:pPr algn="l"/>
-            <a:r>
-              <a:rPr sz="1100" b="0" i="0">
-                <a:solidFill>
-                  <a:srgbClr val="1A1A1A"/>
-                </a:solidFill>
-              </a:rPr>
-              <a:t>• Nommer les missions et valeurs de l'UNICEF au Maroc</a:t>
-            </a:r>
-          </a:p>
-        </p:txBody>
-      </p:sp>
-      <p:sp>
-        <p:nvSpPr>
-          <p:cNvPr id="12" name="TextBox 11"/>
-          <p:cNvSpPr txBox="1"/>
-          <p:nvPr/>
-        </p:nvSpPr>
-        <p:spPr>
-          <a:xfrm>
-            <a:off x="365760" y="1645919"/>
-            <a:ext cx="5303520" cy="347472"/>
-          </a:xfrm>
-          <a:prstGeom prst="rect">
-            <a:avLst/>
-          </a:prstGeom>
-          <a:noFill/>
-        </p:spPr>
-        <p:txBody>
-          <a:bodyPr wrap="square">
-            <a:spAutoFit/>
-          </a:bodyPr>
-          <a:lstStyle/>
-          <a:p>
-            <a:pPr algn="l"/>
-            <a:r>
-              <a:rPr sz="1100" b="0" i="0">
-                <a:solidFill>
-                  <a:srgbClr val="1A1A1A"/>
-                </a:solidFill>
-              </a:rPr>
-              <a:t>• Expliquer le cadre éthique et juridique de la collecte</a:t>
-            </a:r>
-          </a:p>
-        </p:txBody>
-      </p:sp>
-      <p:sp>
-        <p:nvSpPr>
-          <p:cNvPr id="13" name="TextBox 12"/>
-          <p:cNvSpPr txBox="1"/>
-          <p:nvPr/>
-        </p:nvSpPr>
-        <p:spPr>
-          <a:xfrm>
-            <a:off x="365760" y="2011679"/>
-            <a:ext cx="5303520" cy="347472"/>
-          </a:xfrm>
-          <a:prstGeom prst="rect">
-            <a:avLst/>
-          </a:prstGeom>
-          <a:noFill/>
-        </p:spPr>
-        <p:txBody>
-          <a:bodyPr wrap="square">
-            <a:spAutoFit/>
-          </a:bodyPr>
-          <a:lstStyle/>
-          <a:p>
-            <a:pPr algn="l"/>
-            <a:r>
-              <a:rPr sz="1100" b="0" i="0">
-                <a:solidFill>
-                  <a:srgbClr val="1A1A1A"/>
-                </a:solidFill>
-              </a:rPr>
-              <a:t>• Démontrer la posture physique et vocale d'un fundraiser</a:t>
-            </a:r>
-          </a:p>
-        </p:txBody>
-      </p:sp>
-      <p:sp>
-        <p:nvSpPr>
-          <p:cNvPr id="14" name="TextBox 13"/>
-          <p:cNvSpPr txBox="1"/>
-          <p:nvPr/>
-        </p:nvSpPr>
-        <p:spPr>
-          <a:xfrm>
-            <a:off x="365760" y="2377439"/>
-            <a:ext cx="5303520" cy="347472"/>
-          </a:xfrm>
-          <a:prstGeom prst="rect">
-            <a:avLst/>
-          </a:prstGeom>
-          <a:noFill/>
-        </p:spPr>
-        <p:txBody>
-          <a:bodyPr wrap="square">
-            <a:spAutoFit/>
-          </a:bodyPr>
-          <a:lstStyle/>
-          <a:p>
-            <a:pPr algn="l"/>
-            <a:r>
-              <a:rPr sz="1100" b="0" i="0">
-                <a:solidFill>
-                  <a:srgbClr val="1A1A1A"/>
-                </a:solidFill>
-              </a:rPr>
-              <a:t>• Différencier don ponctuel et engagement mensuel</a:t>
-            </a:r>
-          </a:p>
-        </p:txBody>
-      </p:sp>
-      <p:sp>
-        <p:nvSpPr>
-          <p:cNvPr id="15" name="TextBox 14"/>
-          <p:cNvSpPr txBox="1"/>
-          <p:nvPr/>
-        </p:nvSpPr>
-        <p:spPr>
-          <a:xfrm>
-            <a:off x="6217920" y="1280160"/>
-            <a:ext cx="5303520" cy="347472"/>
-          </a:xfrm>
-          <a:prstGeom prst="rect">
-            <a:avLst/>
-          </a:prstGeom>
-          <a:noFill/>
-        </p:spPr>
-        <p:txBody>
-          <a:bodyPr wrap="square">
-            <a:spAutoFit/>
-          </a:bodyPr>
-          <a:lstStyle/>
-          <a:p>
-            <a:pPr algn="l"/>
-            <a:r>
-              <a:rPr sz="1100" b="0" i="0">
-                <a:solidFill>
-                  <a:srgbClr val="1A1A1A"/>
-                </a:solidFill>
-              </a:rPr>
-              <a:t>• Qu'est-ce qu'un fundraiser de rue ? Rôle et légitimité</a:t>
-            </a:r>
-          </a:p>
-        </p:txBody>
-      </p:sp>
-      <p:sp>
-        <p:nvSpPr>
-          <p:cNvPr id="16" name="TextBox 15"/>
-          <p:cNvSpPr txBox="1"/>
-          <p:nvPr/>
-        </p:nvSpPr>
-        <p:spPr>
-          <a:xfrm>
-            <a:off x="6217920" y="1645919"/>
-            <a:ext cx="5303520" cy="347472"/>
-          </a:xfrm>
-          <a:prstGeom prst="rect">
-            <a:avLst/>
-          </a:prstGeom>
-          <a:noFill/>
-        </p:spPr>
-        <p:txBody>
-          <a:bodyPr wrap="square">
-            <a:spAutoFit/>
-          </a:bodyPr>
-          <a:lstStyle/>
-          <a:p>
-            <a:pPr algn="l"/>
-            <a:r>
-              <a:rPr sz="1100" b="0" i="0">
-                <a:solidFill>
-                  <a:srgbClr val="1A1A1A"/>
-                </a:solidFill>
-              </a:rPr>
-              <a:t>• Mission UNICEF Maroc — chiffres 2024–2026</a:t>
-            </a:r>
-          </a:p>
-        </p:txBody>
-      </p:sp>
-      <p:sp>
-        <p:nvSpPr>
-          <p:cNvPr id="17" name="TextBox 16"/>
-          <p:cNvSpPr txBox="1"/>
-          <p:nvPr/>
-        </p:nvSpPr>
-        <p:spPr>
-          <a:xfrm>
-            <a:off x="6217920" y="2011679"/>
-            <a:ext cx="5303520" cy="347472"/>
-          </a:xfrm>
-          <a:prstGeom prst="rect">
-            <a:avLst/>
-          </a:prstGeom>
-          <a:noFill/>
-        </p:spPr>
-        <p:txBody>
-          <a:bodyPr wrap="square">
-            <a:spAutoFit/>
-          </a:bodyPr>
-          <a:lstStyle/>
-          <a:p>
-            <a:pPr algn="l"/>
-            <a:r>
-              <a:rPr sz="1100" b="0" i="0">
-                <a:solidFill>
-                  <a:srgbClr val="1A1A1A"/>
-                </a:solidFill>
-              </a:rPr>
-              <a:t>• Cadre légal Maroc (Loi 75-00) + déontologie</a:t>
-            </a:r>
-          </a:p>
-        </p:txBody>
-      </p:sp>
-      <p:sp>
-        <p:nvSpPr>
-          <p:cNvPr id="18" name="TextBox 17"/>
-          <p:cNvSpPr txBox="1"/>
-          <p:nvPr/>
-        </p:nvSpPr>
-        <p:spPr>
-          <a:xfrm>
-            <a:off x="6217920" y="2377439"/>
-            <a:ext cx="5303520" cy="347472"/>
-          </a:xfrm>
-          <a:prstGeom prst="rect">
-            <a:avLst/>
-          </a:prstGeom>
-          <a:noFill/>
-        </p:spPr>
-        <p:txBody>
-          <a:bodyPr wrap="square">
-            <a:spAutoFit/>
-          </a:bodyPr>
-          <a:lstStyle/>
-          <a:p>
-            <a:pPr algn="l"/>
-            <a:r>
-              <a:rPr sz="1100" b="0" i="0">
-                <a:solidFill>
-                  <a:srgbClr val="1A1A1A"/>
-                </a:solidFill>
-              </a:rPr>
-              <a:t>• Posture corporelle, contact visuel, ton de voix</a:t>
-            </a:r>
-          </a:p>
-        </p:txBody>
-      </p:sp>
-      <p:sp>
-        <p:nvSpPr>
-          <p:cNvPr id="19" name="Rectangle 18"/>
+              <a:t>SHY-Performance  ·  Formation FIM  ·  V6-01062026SHY-TE</a:t>
+            </a:r>
+          </a:p>
+        </p:txBody>
+      </p:sp>
+      <p:sp>
+        <p:nvSpPr>
+          <p:cNvPr id="10" name="Rectangle 9"/>
           <p:cNvSpPr/>
           <p:nvPr/>
         </p:nvSpPr>
         <p:spPr>
           <a:xfrm>
-            <a:off x="274320" y="4160520"/>
-            <a:ext cx="2882646" cy="256032"/>
+            <a:off x="274320" y="804672"/>
+            <a:ext cx="2910078" cy="274320"/>
           </a:xfrm>
           <a:prstGeom prst="rect">
             <a:avLst/>
           </a:prstGeom>
           <a:solidFill>
-            <a:srgbClr val="2E86AB"/>
+            <a:srgbClr val="005555"/>
           </a:solidFill>
           <a:ln>
             <a:noFill/>
@@ -4041,14 +3969,14 @@
       </p:sp>
       <p:sp>
         <p:nvSpPr>
-          <p:cNvPr id="20" name="TextBox 19"/>
+          <p:cNvPr id="11" name="TextBox 10"/>
           <p:cNvSpPr txBox="1"/>
           <p:nvPr/>
         </p:nvSpPr>
         <p:spPr>
           <a:xfrm>
-            <a:off x="320040" y="4187952"/>
-            <a:ext cx="2791206" cy="201168"/>
+            <a:off x="347472" y="841248"/>
+            <a:ext cx="2763774" cy="219456"/>
           </a:xfrm>
           <a:prstGeom prst="rect">
             <a:avLst/>
@@ -4068,21 +3996,21 @@
                   <a:srgbClr val="FFFFFF"/>
                 </a:solidFill>
               </a:rPr>
-              <a:t>EC — Expérience Concrète</a:t>
-            </a:r>
-          </a:p>
-        </p:txBody>
-      </p:sp>
-      <p:sp>
-        <p:nvSpPr>
-          <p:cNvPr id="21" name="Rectangle 20"/>
+              <a:t>DÉCOUVERTE</a:t>
+            </a:r>
+          </a:p>
+        </p:txBody>
+      </p:sp>
+      <p:sp>
+        <p:nvSpPr>
+          <p:cNvPr id="12" name="Rectangle 11"/>
           <p:cNvSpPr/>
           <p:nvPr/>
         </p:nvSpPr>
         <p:spPr>
           <a:xfrm>
-            <a:off x="274320" y="4416552"/>
-            <a:ext cx="2882646" cy="1481328"/>
+            <a:off x="274320" y="1078992"/>
+            <a:ext cx="2910078" cy="3840480"/>
           </a:xfrm>
           <a:prstGeom prst="rect">
             <a:avLst/>
@@ -4092,7 +4020,7 @@
           </a:solidFill>
           <a:ln w="12700">
             <a:solidFill>
-              <a:srgbClr val="2E86AB"/>
+              <a:srgbClr val="005555"/>
             </a:solidFill>
           </a:ln>
         </p:spPr>
@@ -4120,14 +4048,14 @@
       </p:sp>
       <p:sp>
         <p:nvSpPr>
-          <p:cNvPr id="22" name="TextBox 21"/>
+          <p:cNvPr id="13" name="TextBox 12"/>
           <p:cNvSpPr txBox="1"/>
           <p:nvPr/>
         </p:nvSpPr>
         <p:spPr>
           <a:xfrm>
-            <a:off x="365760" y="4453128"/>
-            <a:ext cx="2699765" cy="1371600"/>
+            <a:off x="384048" y="1124712"/>
+            <a:ext cx="2690622" cy="3657600"/>
           </a:xfrm>
           <a:prstGeom prst="rect">
             <a:avLst/>
@@ -4147,27 +4075,29 @@
                   <a:srgbClr val="1A1A1A"/>
                 </a:solidFill>
               </a:rPr>
-              <a:t>Visionnage témoignage bénéficiaire UNICEF (3 min) + réaction individuelle notée</a:t>
-            </a:r>
-          </a:p>
-        </p:txBody>
-      </p:sp>
-      <p:sp>
-        <p:nvSpPr>
-          <p:cNvPr id="23" name="Rectangle 22"/>
+              <a:t>Vous regardez le témoignage
+d'un enfant bénéficiaire.
+Notez ce que vous ressentez.</a:t>
+            </a:r>
+          </a:p>
+        </p:txBody>
+      </p:sp>
+      <p:sp>
+        <p:nvSpPr>
+          <p:cNvPr id="14" name="Rectangle 13"/>
           <p:cNvSpPr/>
           <p:nvPr/>
         </p:nvSpPr>
         <p:spPr>
           <a:xfrm>
-            <a:off x="3184397" y="4160520"/>
-            <a:ext cx="2882646" cy="256032"/>
+            <a:off x="3202686" y="804672"/>
+            <a:ext cx="2910078" cy="274320"/>
           </a:xfrm>
           <a:prstGeom prst="rect">
             <a:avLst/>
           </a:prstGeom>
           <a:solidFill>
-            <a:srgbClr val="4CAF82"/>
+            <a:srgbClr val="008080"/>
           </a:solidFill>
           <a:ln>
             <a:noFill/>
@@ -4197,14 +4127,14 @@
       </p:sp>
       <p:sp>
         <p:nvSpPr>
-          <p:cNvPr id="24" name="TextBox 23"/>
+          <p:cNvPr id="15" name="TextBox 14"/>
           <p:cNvSpPr txBox="1"/>
           <p:nvPr/>
         </p:nvSpPr>
         <p:spPr>
           <a:xfrm>
-            <a:off x="3230117" y="4187952"/>
-            <a:ext cx="2791206" cy="201168"/>
+            <a:off x="3275838" y="841248"/>
+            <a:ext cx="2763774" cy="219456"/>
           </a:xfrm>
           <a:prstGeom prst="rect">
             <a:avLst/>
@@ -4224,21 +4154,21 @@
                   <a:srgbClr val="FFFFFF"/>
                 </a:solidFill>
               </a:rPr>
-              <a:t>OR — Observation Réfléchie</a:t>
-            </a:r>
-          </a:p>
-        </p:txBody>
-      </p:sp>
-      <p:sp>
-        <p:nvSpPr>
-          <p:cNvPr id="25" name="Rectangle 24"/>
+              <a:t>ÉCHANGE</a:t>
+            </a:r>
+          </a:p>
+        </p:txBody>
+      </p:sp>
+      <p:sp>
+        <p:nvSpPr>
+          <p:cNvPr id="16" name="Rectangle 15"/>
           <p:cNvSpPr/>
           <p:nvPr/>
         </p:nvSpPr>
         <p:spPr>
           <a:xfrm>
-            <a:off x="3184397" y="4416552"/>
-            <a:ext cx="2882646" cy="1481328"/>
+            <a:off x="3202686" y="1078992"/>
+            <a:ext cx="2910078" cy="3840480"/>
           </a:xfrm>
           <a:prstGeom prst="rect">
             <a:avLst/>
@@ -4248,7 +4178,7 @@
           </a:solidFill>
           <a:ln w="12700">
             <a:solidFill>
-              <a:srgbClr val="4CAF82"/>
+              <a:srgbClr val="008080"/>
             </a:solidFill>
           </a:ln>
         </p:spPr>
@@ -4276,14 +4206,14 @@
       </p:sp>
       <p:sp>
         <p:nvSpPr>
-          <p:cNvPr id="26" name="TextBox 25"/>
+          <p:cNvPr id="17" name="TextBox 16"/>
           <p:cNvSpPr txBox="1"/>
           <p:nvPr/>
         </p:nvSpPr>
         <p:spPr>
           <a:xfrm>
-            <a:off x="3275837" y="4453128"/>
-            <a:ext cx="2699765" cy="1371600"/>
+            <a:off x="3312414" y="1124712"/>
+            <a:ext cx="2690622" cy="3657600"/>
           </a:xfrm>
           <a:prstGeom prst="rect">
             <a:avLst/>
@@ -4303,27 +4233,29 @@
                   <a:srgbClr val="1A1A1A"/>
                 </a:solidFill>
               </a:rPr>
-              <a:t>Débriefing : 'Qu'avez-vous ressenti ? Qu'auriez-vous dit ?'</a:t>
-            </a:r>
-          </a:p>
-        </p:txBody>
-      </p:sp>
-      <p:sp>
-        <p:nvSpPr>
-          <p:cNvPr id="27" name="Rectangle 26"/>
+              <a:t>En groupe : 'Qu'avez-vous
+ressenti ? Qu'auriez-vous
+dit à cet instant ?'</a:t>
+            </a:r>
+          </a:p>
+        </p:txBody>
+      </p:sp>
+      <p:sp>
+        <p:nvSpPr>
+          <p:cNvPr id="18" name="Rectangle 17"/>
           <p:cNvSpPr/>
           <p:nvPr/>
         </p:nvSpPr>
         <p:spPr>
           <a:xfrm>
-            <a:off x="6094475" y="4160520"/>
-            <a:ext cx="2882646" cy="256032"/>
+            <a:off x="6131052" y="804672"/>
+            <a:ext cx="2910078" cy="274320"/>
           </a:xfrm>
           <a:prstGeom prst="rect">
             <a:avLst/>
           </a:prstGeom>
           <a:solidFill>
-            <a:srgbClr val="F4AE2D"/>
+            <a:srgbClr val="2A7A50"/>
           </a:solidFill>
           <a:ln>
             <a:noFill/>
@@ -4353,14 +4285,14 @@
       </p:sp>
       <p:sp>
         <p:nvSpPr>
-          <p:cNvPr id="28" name="TextBox 27"/>
+          <p:cNvPr id="19" name="TextBox 18"/>
           <p:cNvSpPr txBox="1"/>
           <p:nvPr/>
         </p:nvSpPr>
         <p:spPr>
           <a:xfrm>
-            <a:off x="6140195" y="4187952"/>
-            <a:ext cx="2791206" cy="201168"/>
+            <a:off x="6204204" y="841248"/>
+            <a:ext cx="2763774" cy="219456"/>
           </a:xfrm>
           <a:prstGeom prst="rect">
             <a:avLst/>
@@ -4380,21 +4312,21 @@
                   <a:srgbClr val="FFFFFF"/>
                 </a:solidFill>
               </a:rPr>
-              <a:t>CA — Conceptualisation</a:t>
-            </a:r>
-          </a:p>
-        </p:txBody>
-      </p:sp>
-      <p:sp>
-        <p:nvSpPr>
-          <p:cNvPr id="29" name="Rectangle 28"/>
+              <a:t>APPORT</a:t>
+            </a:r>
+          </a:p>
+        </p:txBody>
+      </p:sp>
+      <p:sp>
+        <p:nvSpPr>
+          <p:cNvPr id="20" name="Rectangle 19"/>
           <p:cNvSpPr/>
           <p:nvPr/>
         </p:nvSpPr>
         <p:spPr>
           <a:xfrm>
-            <a:off x="6094475" y="4416552"/>
-            <a:ext cx="2882646" cy="1481328"/>
+            <a:off x="6131052" y="1078992"/>
+            <a:ext cx="2910078" cy="3840480"/>
           </a:xfrm>
           <a:prstGeom prst="rect">
             <a:avLst/>
@@ -4404,7 +4336,7 @@
           </a:solidFill>
           <a:ln w="12700">
             <a:solidFill>
-              <a:srgbClr val="F4AE2D"/>
+              <a:srgbClr val="2A7A50"/>
             </a:solidFill>
           </a:ln>
         </p:spPr>
@@ -4432,14 +4364,14 @@
       </p:sp>
       <p:sp>
         <p:nvSpPr>
-          <p:cNvPr id="30" name="TextBox 29"/>
+          <p:cNvPr id="21" name="TextBox 20"/>
           <p:cNvSpPr txBox="1"/>
           <p:nvPr/>
         </p:nvSpPr>
         <p:spPr>
           <a:xfrm>
-            <a:off x="6185915" y="4453128"/>
-            <a:ext cx="2699765" cy="1371600"/>
+            <a:off x="6240780" y="1124712"/>
+            <a:ext cx="2690622" cy="3657600"/>
           </a:xfrm>
           <a:prstGeom prst="rect">
             <a:avLst/>
@@ -4459,27 +4391,29 @@
                   <a:srgbClr val="1A1A1A"/>
                 </a:solidFill>
               </a:rPr>
-              <a:t>Apport : structure UNICEF, chiffres clés, cadre légal Maroc</a:t>
-            </a:r>
-          </a:p>
-        </p:txBody>
-      </p:sp>
-      <p:sp>
-        <p:nvSpPr>
-          <p:cNvPr id="31" name="Rectangle 30"/>
+              <a:t>L'UNICEF en chiffres.
+La cause. Le cadre.
+Vos droits et devoirs.</a:t>
+            </a:r>
+          </a:p>
+        </p:txBody>
+      </p:sp>
+      <p:sp>
+        <p:nvSpPr>
+          <p:cNvPr id="22" name="Rectangle 21"/>
           <p:cNvSpPr/>
           <p:nvPr/>
         </p:nvSpPr>
         <p:spPr>
           <a:xfrm>
-            <a:off x="9004554" y="4160520"/>
-            <a:ext cx="2882646" cy="256032"/>
+            <a:off x="9059418" y="804672"/>
+            <a:ext cx="2910078" cy="274320"/>
           </a:xfrm>
           <a:prstGeom prst="rect">
             <a:avLst/>
           </a:prstGeom>
           <a:solidFill>
-            <a:srgbClr val="E84855"/>
+            <a:srgbClr val="FF0000"/>
           </a:solidFill>
           <a:ln>
             <a:noFill/>
@@ -4509,14 +4443,14 @@
       </p:sp>
       <p:sp>
         <p:nvSpPr>
-          <p:cNvPr id="32" name="TextBox 31"/>
+          <p:cNvPr id="23" name="TextBox 22"/>
           <p:cNvSpPr txBox="1"/>
           <p:nvPr/>
         </p:nvSpPr>
         <p:spPr>
           <a:xfrm>
-            <a:off x="9050274" y="4187952"/>
-            <a:ext cx="2791206" cy="201168"/>
+            <a:off x="9132570" y="841248"/>
+            <a:ext cx="2763774" cy="219456"/>
           </a:xfrm>
           <a:prstGeom prst="rect">
             <a:avLst/>
@@ -4536,21 +4470,21 @@
                   <a:srgbClr val="FFFFFF"/>
                 </a:solidFill>
               </a:rPr>
-              <a:t>EA — Expérimentation Active</a:t>
-            </a:r>
-          </a:p>
-        </p:txBody>
-      </p:sp>
-      <p:sp>
-        <p:nvSpPr>
-          <p:cNvPr id="33" name="Rectangle 32"/>
+              <a:t>MISE EN PRATIQUE</a:t>
+            </a:r>
+          </a:p>
+        </p:txBody>
+      </p:sp>
+      <p:sp>
+        <p:nvSpPr>
+          <p:cNvPr id="24" name="Rectangle 23"/>
           <p:cNvSpPr/>
           <p:nvPr/>
         </p:nvSpPr>
         <p:spPr>
           <a:xfrm>
-            <a:off x="9004554" y="4416552"/>
-            <a:ext cx="2882646" cy="1481328"/>
+            <a:off x="9059418" y="1078992"/>
+            <a:ext cx="2910078" cy="3840480"/>
           </a:xfrm>
           <a:prstGeom prst="rect">
             <a:avLst/>
@@ -4560,7 +4494,7 @@
           </a:solidFill>
           <a:ln w="12700">
             <a:solidFill>
-              <a:srgbClr val="E84855"/>
+              <a:srgbClr val="FF0000"/>
             </a:solidFill>
           </a:ln>
         </p:spPr>
@@ -4588,14 +4522,14 @@
       </p:sp>
       <p:sp>
         <p:nvSpPr>
-          <p:cNvPr id="34" name="TextBox 33"/>
+          <p:cNvPr id="25" name="TextBox 24"/>
           <p:cNvSpPr txBox="1"/>
           <p:nvPr/>
         </p:nvSpPr>
         <p:spPr>
           <a:xfrm>
-            <a:off x="9095994" y="4453128"/>
-            <a:ext cx="2699765" cy="1371600"/>
+            <a:off x="9169146" y="1124712"/>
+            <a:ext cx="2690622" cy="3657600"/>
           </a:xfrm>
           <a:prstGeom prst="rect">
             <a:avLst/>
@@ -4615,27 +4549,29 @@
                   <a:srgbClr val="1A1A1A"/>
                 </a:solidFill>
               </a:rPr>
-              <a:t>Jeu de rôle : 'Expliquez la mission UNICEF en 60 secondes'</a:t>
-            </a:r>
-          </a:p>
-        </p:txBody>
-      </p:sp>
-      <p:sp>
-        <p:nvSpPr>
-          <p:cNvPr id="35" name="Rectangle 34"/>
+              <a:t>Vous présentez la mission
+UNICEF en 60 secondes
+à votre binôme.</a:t>
+            </a:r>
+          </a:p>
+        </p:txBody>
+      </p:sp>
+      <p:sp>
+        <p:nvSpPr>
+          <p:cNvPr id="26" name="Rectangle 25"/>
           <p:cNvSpPr/>
           <p:nvPr/>
         </p:nvSpPr>
         <p:spPr>
           <a:xfrm>
-            <a:off x="274320" y="5486400"/>
-            <a:ext cx="11612880" cy="274320"/>
+            <a:off x="274320" y="5074920"/>
+            <a:ext cx="11640312" cy="274320"/>
           </a:xfrm>
           <a:prstGeom prst="rect">
             <a:avLst/>
           </a:prstGeom>
           <a:solidFill>
-            <a:srgbClr val="C9A84C"/>
+            <a:srgbClr val="FF0000"/>
           </a:solidFill>
           <a:ln>
             <a:noFill/>
@@ -4665,13 +4601,13 @@
       </p:sp>
       <p:sp>
         <p:nvSpPr>
-          <p:cNvPr id="36" name="TextBox 35"/>
+          <p:cNvPr id="27" name="TextBox 26"/>
           <p:cNvSpPr txBox="1"/>
           <p:nvPr/>
         </p:nvSpPr>
         <p:spPr>
           <a:xfrm>
-            <a:off x="365760" y="5522976"/>
+            <a:off x="384048" y="5111496"/>
             <a:ext cx="11430000" cy="219456"/>
           </a:xfrm>
           <a:prstGeom prst="rect">
@@ -4687,26 +4623,71 @@
           <a:p>
             <a:pPr algn="l"/>
             <a:r>
-              <a:rPr sz="1000" b="1" i="0">
+              <a:rPr sz="900" b="1" i="0">
                 <a:solidFill>
-                  <a:srgbClr val="005050"/>
+                  <a:srgbClr val="FFFFFF"/>
                 </a:solidFill>
               </a:rPr>
-              <a:t>🎯 Évaluation formative J1</a:t>
-            </a:r>
-          </a:p>
-        </p:txBody>
-      </p:sp>
-      <p:sp>
-        <p:nvSpPr>
-          <p:cNvPr id="37" name="TextBox 36"/>
+              <a:t>Vos 3 réussites à valider aujourd'hui</a:t>
+            </a:r>
+          </a:p>
+        </p:txBody>
+      </p:sp>
+      <p:sp>
+        <p:nvSpPr>
+          <p:cNvPr id="28" name="Rectangle 27"/>
+          <p:cNvSpPr/>
+          <p:nvPr/>
+        </p:nvSpPr>
+        <p:spPr>
+          <a:xfrm>
+            <a:off x="274320" y="5367528"/>
+            <a:ext cx="3843528" cy="502920"/>
+          </a:xfrm>
+          <a:prstGeom prst="rect">
+            <a:avLst/>
+          </a:prstGeom>
+          <a:solidFill>
+            <a:srgbClr val="FFFFFF"/>
+          </a:solidFill>
+          <a:ln w="10160">
+            <a:solidFill>
+              <a:srgbClr val="FF0000"/>
+            </a:solidFill>
+          </a:ln>
+        </p:spPr>
+        <p:style>
+          <a:lnRef idx="1">
+            <a:schemeClr val="accent1"/>
+          </a:lnRef>
+          <a:fillRef idx="3">
+            <a:schemeClr val="accent1"/>
+          </a:fillRef>
+          <a:effectRef idx="2">
+            <a:schemeClr val="accent1"/>
+          </a:effectRef>
+          <a:fontRef idx="minor">
+            <a:schemeClr val="lt1"/>
+          </a:fontRef>
+        </p:style>
+        <p:txBody>
+          <a:bodyPr rtlCol="0" anchor="ctr"/>
+          <a:lstStyle/>
+          <a:p>
+            <a:pPr algn="ctr"/>
+          </a:p>
+        </p:txBody>
+      </p:sp>
+      <p:sp>
+        <p:nvSpPr>
+          <p:cNvPr id="29" name="TextBox 28"/>
           <p:cNvSpPr txBox="1"/>
           <p:nvPr/>
         </p:nvSpPr>
         <p:spPr>
           <a:xfrm>
-            <a:off x="365760" y="5779008"/>
-            <a:ext cx="3718560" cy="502920"/>
+            <a:off x="365760" y="5404104"/>
+            <a:ext cx="3715512" cy="420624"/>
           </a:xfrm>
           <a:prstGeom prst="rect">
             <a:avLst/>
@@ -4726,21 +4707,66 @@
                   <a:srgbClr val="1A1A1A"/>
                 </a:solidFill>
               </a:rPr>
-              <a:t>✓ Pitch 60s — grille C1+C2+C7 (formateur + auto-éval)</a:t>
-            </a:r>
-          </a:p>
-        </p:txBody>
-      </p:sp>
-      <p:sp>
-        <p:nvSpPr>
-          <p:cNvPr id="38" name="TextBox 37"/>
+              <a:t>✔ Pitch 60s évalué avec votre formateur</a:t>
+            </a:r>
+          </a:p>
+        </p:txBody>
+      </p:sp>
+      <p:sp>
+        <p:nvSpPr>
+          <p:cNvPr id="30" name="Rectangle 29"/>
+          <p:cNvSpPr/>
+          <p:nvPr/>
+        </p:nvSpPr>
+        <p:spPr>
+          <a:xfrm>
+            <a:off x="4154423" y="5367528"/>
+            <a:ext cx="3843528" cy="502920"/>
+          </a:xfrm>
+          <a:prstGeom prst="rect">
+            <a:avLst/>
+          </a:prstGeom>
+          <a:solidFill>
+            <a:srgbClr val="FFFFFF"/>
+          </a:solidFill>
+          <a:ln w="10160">
+            <a:solidFill>
+              <a:srgbClr val="FF0000"/>
+            </a:solidFill>
+          </a:ln>
+        </p:spPr>
+        <p:style>
+          <a:lnRef idx="1">
+            <a:schemeClr val="accent1"/>
+          </a:lnRef>
+          <a:fillRef idx="3">
+            <a:schemeClr val="accent1"/>
+          </a:fillRef>
+          <a:effectRef idx="2">
+            <a:schemeClr val="accent1"/>
+          </a:effectRef>
+          <a:fontRef idx="minor">
+            <a:schemeClr val="lt1"/>
+          </a:fontRef>
+        </p:style>
+        <p:txBody>
+          <a:bodyPr rtlCol="0" anchor="ctr"/>
+          <a:lstStyle/>
+          <a:p>
+            <a:pPr algn="ctr"/>
+          </a:p>
+        </p:txBody>
+      </p:sp>
+      <p:sp>
+        <p:nvSpPr>
+          <p:cNvPr id="31" name="TextBox 30"/>
           <p:cNvSpPr txBox="1"/>
           <p:nvPr/>
         </p:nvSpPr>
         <p:spPr>
           <a:xfrm>
-            <a:off x="4175760" y="5779008"/>
-            <a:ext cx="3718560" cy="502920"/>
+            <a:off x="4245863" y="5404104"/>
+            <a:ext cx="3715512" cy="420624"/>
           </a:xfrm>
           <a:prstGeom prst="rect">
             <a:avLst/>
@@ -4760,21 +4786,66 @@
                   <a:srgbClr val="1A1A1A"/>
                 </a:solidFill>
               </a:rPr>
-              <a:t>✓ Quiz 5Q chiffres UNICEF — seuil 60%</a:t>
-            </a:r>
-          </a:p>
-        </p:txBody>
-      </p:sp>
-      <p:sp>
-        <p:nvSpPr>
-          <p:cNvPr id="39" name="TextBox 38"/>
+              <a:t>✔ Quiz 5 questions UNICEF (seuil 60%)</a:t>
+            </a:r>
+          </a:p>
+        </p:txBody>
+      </p:sp>
+      <p:sp>
+        <p:nvSpPr>
+          <p:cNvPr id="32" name="Rectangle 31"/>
+          <p:cNvSpPr/>
+          <p:nvPr/>
+        </p:nvSpPr>
+        <p:spPr>
+          <a:xfrm>
+            <a:off x="8034527" y="5367528"/>
+            <a:ext cx="3843528" cy="502920"/>
+          </a:xfrm>
+          <a:prstGeom prst="rect">
+            <a:avLst/>
+          </a:prstGeom>
+          <a:solidFill>
+            <a:srgbClr val="FFFFFF"/>
+          </a:solidFill>
+          <a:ln w="10160">
+            <a:solidFill>
+              <a:srgbClr val="FF0000"/>
+            </a:solidFill>
+          </a:ln>
+        </p:spPr>
+        <p:style>
+          <a:lnRef idx="1">
+            <a:schemeClr val="accent1"/>
+          </a:lnRef>
+          <a:fillRef idx="3">
+            <a:schemeClr val="accent1"/>
+          </a:fillRef>
+          <a:effectRef idx="2">
+            <a:schemeClr val="accent1"/>
+          </a:effectRef>
+          <a:fontRef idx="minor">
+            <a:schemeClr val="lt1"/>
+          </a:fontRef>
+        </p:style>
+        <p:txBody>
+          <a:bodyPr rtlCol="0" anchor="ctr"/>
+          <a:lstStyle/>
+          <a:p>
+            <a:pPr algn="ctr"/>
+          </a:p>
+        </p:txBody>
+      </p:sp>
+      <p:sp>
+        <p:nvSpPr>
+          <p:cNvPr id="33" name="TextBox 32"/>
           <p:cNvSpPr txBox="1"/>
           <p:nvPr/>
         </p:nvSpPr>
         <p:spPr>
           <a:xfrm>
-            <a:off x="7985760" y="5779008"/>
-            <a:ext cx="3718560" cy="502920"/>
+            <a:off x="8125967" y="5404104"/>
+            <a:ext cx="3715512" cy="420624"/>
           </a:xfrm>
           <a:prstGeom prst="rect">
             <a:avLst/>
@@ -4794,7 +4865,7 @@
                   <a:srgbClr val="1A1A1A"/>
                 </a:solidFill>
               </a:rPr>
-              <a:t>✓ Réflexion écrite 5 lignes dans le LFI</a:t>
+              <a:t>✔ 3 lignes dans votre livret personnel</a:t>
             </a:r>
           </a:p>
         </p:txBody>
@@ -4869,13 +4940,13 @@
         <p:spPr>
           <a:xfrm>
             <a:off x="0" y="0"/>
-            <a:ext cx="12188952" cy="685800"/>
+            <a:ext cx="12188952" cy="658368"/>
           </a:xfrm>
           <a:prstGeom prst="rect">
             <a:avLst/>
           </a:prstGeom>
           <a:solidFill>
-            <a:srgbClr val="005050"/>
+            <a:srgbClr val="005555"/>
           </a:solidFill>
           <a:ln>
             <a:noFill/>
@@ -4911,14 +4982,14 @@
         </p:nvSpPr>
         <p:spPr>
           <a:xfrm>
-            <a:off x="0" y="667512"/>
-            <a:ext cx="12188952" cy="36576"/>
+            <a:off x="0" y="640080"/>
+            <a:ext cx="12188952" cy="54864"/>
           </a:xfrm>
           <a:prstGeom prst="rect">
             <a:avLst/>
           </a:prstGeom>
           <a:solidFill>
-            <a:srgbClr val="C9A84C"/>
+            <a:srgbClr val="FF0000"/>
           </a:solidFill>
           <a:ln>
             <a:noFill/>
@@ -4954,8 +5025,8 @@
         </p:nvSpPr>
         <p:spPr>
           <a:xfrm>
-            <a:off x="274320" y="73152"/>
-            <a:ext cx="11612880" cy="566928"/>
+            <a:off x="164592" y="64008"/>
+            <a:ext cx="685800" cy="530352"/>
           </a:xfrm>
           <a:prstGeom prst="rect">
             <a:avLst/>
@@ -4970,12 +5041,12 @@
           <a:p>
             <a:pPr algn="l"/>
             <a:r>
-              <a:rPr sz="1800" b="1" i="0">
+              <a:rPr sz="2000" b="1" i="0">
                 <a:solidFill>
                   <a:srgbClr val="FFFFFF"/>
                 </a:solidFill>
               </a:rPr>
-              <a:t>UNICEF Maroc &amp; International — Chiffres clés 2024–2026</a:t>
+              <a:t>SHY</a:t>
             </a:r>
           </a:p>
         </p:txBody>
@@ -4988,14 +5059,14 @@
         </p:nvSpPr>
         <p:spPr>
           <a:xfrm>
-            <a:off x="274320" y="868680"/>
-            <a:ext cx="1920240" cy="1005840"/>
+            <a:off x="914400" y="91440"/>
+            <a:ext cx="36576" cy="475488"/>
           </a:xfrm>
           <a:prstGeom prst="rect">
             <a:avLst/>
           </a:prstGeom>
           <a:solidFill>
-            <a:srgbClr val="007A7A"/>
+            <a:srgbClr val="FF0000"/>
           </a:solidFill>
           <a:ln>
             <a:noFill/>
@@ -5031,7 +5102,161 @@
         </p:nvSpPr>
         <p:spPr>
           <a:xfrm>
-            <a:off x="365760" y="896112"/>
+            <a:off x="1024128" y="91440"/>
+            <a:ext cx="10881360" cy="475488"/>
+          </a:xfrm>
+          <a:prstGeom prst="rect">
+            <a:avLst/>
+          </a:prstGeom>
+          <a:noFill/>
+        </p:spPr>
+        <p:txBody>
+          <a:bodyPr wrap="square">
+            <a:spAutoFit/>
+          </a:bodyPr>
+          <a:lstStyle/>
+          <a:p>
+            <a:pPr algn="l"/>
+            <a:r>
+              <a:rPr sz="1700" b="1" i="0">
+                <a:solidFill>
+                  <a:srgbClr val="FFFFFF"/>
+                </a:solidFill>
+              </a:rPr>
+              <a:t>L'UNICEF — La cause que vous défendez</a:t>
+            </a:r>
+          </a:p>
+        </p:txBody>
+      </p:sp>
+      <p:sp>
+        <p:nvSpPr>
+          <p:cNvPr id="8" name="Rectangle 7"/>
+          <p:cNvSpPr/>
+          <p:nvPr/>
+        </p:nvSpPr>
+        <p:spPr>
+          <a:xfrm>
+            <a:off x="0" y="6492240"/>
+            <a:ext cx="12188952" cy="365760"/>
+          </a:xfrm>
+          <a:prstGeom prst="rect">
+            <a:avLst/>
+          </a:prstGeom>
+          <a:solidFill>
+            <a:srgbClr val="005555"/>
+          </a:solidFill>
+          <a:ln>
+            <a:noFill/>
+          </a:ln>
+        </p:spPr>
+        <p:style>
+          <a:lnRef idx="1">
+            <a:schemeClr val="accent1"/>
+          </a:lnRef>
+          <a:fillRef idx="3">
+            <a:schemeClr val="accent1"/>
+          </a:fillRef>
+          <a:effectRef idx="2">
+            <a:schemeClr val="accent1"/>
+          </a:effectRef>
+          <a:fontRef idx="minor">
+            <a:schemeClr val="lt1"/>
+          </a:fontRef>
+        </p:style>
+        <p:txBody>
+          <a:bodyPr rtlCol="0" anchor="ctr"/>
+          <a:lstStyle/>
+          <a:p>
+            <a:pPr algn="ctr"/>
+          </a:p>
+        </p:txBody>
+      </p:sp>
+      <p:sp>
+        <p:nvSpPr>
+          <p:cNvPr id="9" name="TextBox 8"/>
+          <p:cNvSpPr txBox="1"/>
+          <p:nvPr/>
+        </p:nvSpPr>
+        <p:spPr>
+          <a:xfrm>
+            <a:off x="0" y="6519672"/>
+            <a:ext cx="12188952" cy="274320"/>
+          </a:xfrm>
+          <a:prstGeom prst="rect">
+            <a:avLst/>
+          </a:prstGeom>
+          <a:noFill/>
+        </p:spPr>
+        <p:txBody>
+          <a:bodyPr wrap="square">
+            <a:spAutoFit/>
+          </a:bodyPr>
+          <a:lstStyle/>
+          <a:p>
+            <a:pPr algn="ctr"/>
+            <a:r>
+              <a:rPr sz="900" b="0" i="0">
+                <a:solidFill>
+                  <a:srgbClr val="FFFFFF"/>
+                </a:solidFill>
+              </a:rPr>
+              <a:t>SHY-Performance  ·  Formation FIM  ·  V6-01062026SHY-TE</a:t>
+            </a:r>
+          </a:p>
+        </p:txBody>
+      </p:sp>
+      <p:sp>
+        <p:nvSpPr>
+          <p:cNvPr id="10" name="Rectangle 9"/>
+          <p:cNvSpPr/>
+          <p:nvPr/>
+        </p:nvSpPr>
+        <p:spPr>
+          <a:xfrm>
+            <a:off x="274320" y="804672"/>
+            <a:ext cx="1920240" cy="987552"/>
+          </a:xfrm>
+          <a:prstGeom prst="rect">
+            <a:avLst/>
+          </a:prstGeom>
+          <a:solidFill>
+            <a:srgbClr val="005555"/>
+          </a:solidFill>
+          <a:ln>
+            <a:noFill/>
+          </a:ln>
+        </p:spPr>
+        <p:style>
+          <a:lnRef idx="1">
+            <a:schemeClr val="accent1"/>
+          </a:lnRef>
+          <a:fillRef idx="3">
+            <a:schemeClr val="accent1"/>
+          </a:fillRef>
+          <a:effectRef idx="2">
+            <a:schemeClr val="accent1"/>
+          </a:effectRef>
+          <a:fontRef idx="minor">
+            <a:schemeClr val="lt1"/>
+          </a:fontRef>
+        </p:style>
+        <p:txBody>
+          <a:bodyPr rtlCol="0" anchor="ctr"/>
+          <a:lstStyle/>
+          <a:p>
+            <a:pPr algn="ctr"/>
+          </a:p>
+        </p:txBody>
+      </p:sp>
+      <p:sp>
+        <p:nvSpPr>
+          <p:cNvPr id="11" name="TextBox 10"/>
+          <p:cNvSpPr txBox="1"/>
+          <p:nvPr/>
+        </p:nvSpPr>
+        <p:spPr>
+          <a:xfrm>
+            <a:off x="365760" y="822960"/>
             <a:ext cx="1737360" cy="594360"/>
           </a:xfrm>
           <a:prstGeom prst="rect">
@@ -5059,13 +5284,13 @@
       </p:sp>
       <p:sp>
         <p:nvSpPr>
-          <p:cNvPr id="8" name="TextBox 7"/>
+          <p:cNvPr id="12" name="TextBox 11"/>
           <p:cNvSpPr txBox="1"/>
           <p:nvPr/>
         </p:nvSpPr>
         <p:spPr>
           <a:xfrm>
-            <a:off x="365760" y="1481328"/>
+            <a:off x="365760" y="1408176"/>
             <a:ext cx="1737360" cy="365760"/>
           </a:xfrm>
           <a:prstGeom prst="rect">
@@ -5083,30 +5308,31 @@
             <a:r>
               <a:rPr sz="900" b="0" i="0">
                 <a:solidFill>
-                  <a:srgbClr val="DDEEEE"/>
+                  <a:srgbClr val="CCEEEE"/>
                 </a:solidFill>
               </a:rPr>
-              <a:t>pays où l'UNICEF est présent</a:t>
-            </a:r>
-          </a:p>
-        </p:txBody>
-      </p:sp>
-      <p:sp>
-        <p:nvSpPr>
-          <p:cNvPr id="9" name="Rectangle 8"/>
+              <a:t>pays où l'UNICEF
+est présent</a:t>
+            </a:r>
+          </a:p>
+        </p:txBody>
+      </p:sp>
+      <p:sp>
+        <p:nvSpPr>
+          <p:cNvPr id="13" name="Rectangle 12"/>
           <p:cNvSpPr/>
           <p:nvPr/>
         </p:nvSpPr>
         <p:spPr>
           <a:xfrm>
-            <a:off x="2240279" y="868680"/>
-            <a:ext cx="1920240" cy="1005840"/>
+            <a:off x="2240279" y="804672"/>
+            <a:ext cx="1920240" cy="987552"/>
           </a:xfrm>
           <a:prstGeom prst="rect">
             <a:avLst/>
           </a:prstGeom>
           <a:solidFill>
-            <a:srgbClr val="007A7A"/>
+            <a:srgbClr val="005555"/>
           </a:solidFill>
           <a:ln>
             <a:noFill/>
@@ -5136,13 +5362,13 @@
       </p:sp>
       <p:sp>
         <p:nvSpPr>
-          <p:cNvPr id="10" name="TextBox 9"/>
+          <p:cNvPr id="14" name="TextBox 13"/>
           <p:cNvSpPr txBox="1"/>
           <p:nvPr/>
         </p:nvSpPr>
         <p:spPr>
           <a:xfrm>
-            <a:off x="2331720" y="896112"/>
+            <a:off x="2331720" y="822960"/>
             <a:ext cx="1737360" cy="594360"/>
           </a:xfrm>
           <a:prstGeom prst="rect">
@@ -5170,13 +5396,13 @@
       </p:sp>
       <p:sp>
         <p:nvSpPr>
-          <p:cNvPr id="11" name="TextBox 10"/>
+          <p:cNvPr id="15" name="TextBox 14"/>
           <p:cNvSpPr txBox="1"/>
           <p:nvPr/>
         </p:nvSpPr>
         <p:spPr>
           <a:xfrm>
-            <a:off x="2331720" y="1481328"/>
+            <a:off x="2331720" y="1408176"/>
             <a:ext cx="1737360" cy="365760"/>
           </a:xfrm>
           <a:prstGeom prst="rect">
@@ -5194,30 +5420,31 @@
             <a:r>
               <a:rPr sz="900" b="0" i="0">
                 <a:solidFill>
-                  <a:srgbClr val="DDEEEE"/>
+                  <a:srgbClr val="CCEEEE"/>
                 </a:solidFill>
               </a:rPr>
-              <a:t>enfants aidés chaque année</a:t>
-            </a:r>
-          </a:p>
-        </p:txBody>
-      </p:sp>
-      <p:sp>
-        <p:nvSpPr>
-          <p:cNvPr id="12" name="Rectangle 11"/>
+              <a:t>enfants aidés
+chaque année</a:t>
+            </a:r>
+          </a:p>
+        </p:txBody>
+      </p:sp>
+      <p:sp>
+        <p:nvSpPr>
+          <p:cNvPr id="16" name="Rectangle 15"/>
           <p:cNvSpPr/>
           <p:nvPr/>
         </p:nvSpPr>
         <p:spPr>
           <a:xfrm>
-            <a:off x="4206240" y="868680"/>
-            <a:ext cx="1920240" cy="1005840"/>
+            <a:off x="4206240" y="804672"/>
+            <a:ext cx="1920240" cy="987552"/>
           </a:xfrm>
           <a:prstGeom prst="rect">
             <a:avLst/>
           </a:prstGeom>
           <a:solidFill>
-            <a:srgbClr val="007A7A"/>
+            <a:srgbClr val="005555"/>
           </a:solidFill>
           <a:ln>
             <a:noFill/>
@@ -5247,13 +5474,13 @@
       </p:sp>
       <p:sp>
         <p:nvSpPr>
-          <p:cNvPr id="13" name="TextBox 12"/>
+          <p:cNvPr id="17" name="TextBox 16"/>
           <p:cNvSpPr txBox="1"/>
           <p:nvPr/>
         </p:nvSpPr>
         <p:spPr>
           <a:xfrm>
-            <a:off x="4297679" y="896112"/>
+            <a:off x="4297679" y="822960"/>
             <a:ext cx="1737360" cy="594360"/>
           </a:xfrm>
           <a:prstGeom prst="rect">
@@ -5274,20 +5501,20 @@
                   <a:srgbClr val="FFFFFF"/>
                 </a:solidFill>
               </a:rPr>
-              <a:t>46M€</a:t>
-            </a:r>
-          </a:p>
-        </p:txBody>
-      </p:sp>
-      <p:sp>
-        <p:nvSpPr>
-          <p:cNvPr id="14" name="TextBox 13"/>
+              <a:t>830M€</a:t>
+            </a:r>
+          </a:p>
+        </p:txBody>
+      </p:sp>
+      <p:sp>
+        <p:nvSpPr>
+          <p:cNvPr id="18" name="TextBox 17"/>
           <p:cNvSpPr txBox="1"/>
           <p:nvPr/>
         </p:nvSpPr>
         <p:spPr>
           <a:xfrm>
-            <a:off x="4297679" y="1481328"/>
+            <a:off x="4297679" y="1408176"/>
             <a:ext cx="1737360" cy="365760"/>
           </a:xfrm>
           <a:prstGeom prst="rect">
@@ -5305,30 +5532,31 @@
             <a:r>
               <a:rPr sz="900" b="0" i="0">
                 <a:solidFill>
-                  <a:srgbClr val="DDEEEE"/>
+                  <a:srgbClr val="CCEEEE"/>
                 </a:solidFill>
               </a:rPr>
-              <a:t>budget UNICEF Maroc 2024</a:t>
-            </a:r>
-          </a:p>
-        </p:txBody>
-      </p:sp>
-      <p:sp>
-        <p:nvSpPr>
-          <p:cNvPr id="15" name="Rectangle 14"/>
+              <a:t>collectés en France
+en 2024</a:t>
+            </a:r>
+          </a:p>
+        </p:txBody>
+      </p:sp>
+      <p:sp>
+        <p:nvSpPr>
+          <p:cNvPr id="19" name="Rectangle 18"/>
           <p:cNvSpPr/>
           <p:nvPr/>
         </p:nvSpPr>
         <p:spPr>
           <a:xfrm>
-            <a:off x="6172200" y="868680"/>
-            <a:ext cx="1920240" cy="1005840"/>
+            <a:off x="6172200" y="804672"/>
+            <a:ext cx="1920240" cy="987552"/>
           </a:xfrm>
           <a:prstGeom prst="rect">
             <a:avLst/>
           </a:prstGeom>
           <a:solidFill>
-            <a:srgbClr val="007A7A"/>
+            <a:srgbClr val="005555"/>
           </a:solidFill>
           <a:ln>
             <a:noFill/>
@@ -5358,124 +5586,13 @@
       </p:sp>
       <p:sp>
         <p:nvSpPr>
-          <p:cNvPr id="16" name="TextBox 15"/>
+          <p:cNvPr id="20" name="TextBox 19"/>
           <p:cNvSpPr txBox="1"/>
           <p:nvPr/>
         </p:nvSpPr>
         <p:spPr>
           <a:xfrm>
-            <a:off x="6263640" y="896112"/>
-            <a:ext cx="1737360" cy="594360"/>
-          </a:xfrm>
-          <a:prstGeom prst="rect">
-            <a:avLst/>
-          </a:prstGeom>
-          <a:noFill/>
-        </p:spPr>
-        <p:txBody>
-          <a:bodyPr wrap="square">
-            <a:spAutoFit/>
-          </a:bodyPr>
-          <a:lstStyle/>
-          <a:p>
-            <a:pPr algn="ctr"/>
-            <a:r>
-              <a:rPr sz="2600" b="1" i="0">
-                <a:solidFill>
-                  <a:srgbClr val="FFFFFF"/>
-                </a:solidFill>
-              </a:rPr>
-              <a:t>3,2M</a:t>
-            </a:r>
-          </a:p>
-        </p:txBody>
-      </p:sp>
-      <p:sp>
-        <p:nvSpPr>
-          <p:cNvPr id="17" name="TextBox 16"/>
-          <p:cNvSpPr txBox="1"/>
-          <p:nvPr/>
-        </p:nvSpPr>
-        <p:spPr>
-          <a:xfrm>
-            <a:off x="6263640" y="1481328"/>
-            <a:ext cx="1737360" cy="365760"/>
-          </a:xfrm>
-          <a:prstGeom prst="rect">
-            <a:avLst/>
-          </a:prstGeom>
-          <a:noFill/>
-        </p:spPr>
-        <p:txBody>
-          <a:bodyPr wrap="square">
-            <a:spAutoFit/>
-          </a:bodyPr>
-          <a:lstStyle/>
-          <a:p>
-            <a:pPr algn="ctr"/>
-            <a:r>
-              <a:rPr sz="900" b="0" i="0">
-                <a:solidFill>
-                  <a:srgbClr val="DDEEEE"/>
-                </a:solidFill>
-              </a:rPr>
-              <a:t>enfants bénéficiaires au Maroc</a:t>
-            </a:r>
-          </a:p>
-        </p:txBody>
-      </p:sp>
-      <p:sp>
-        <p:nvSpPr>
-          <p:cNvPr id="18" name="Rectangle 17"/>
-          <p:cNvSpPr/>
-          <p:nvPr/>
-        </p:nvSpPr>
-        <p:spPr>
-          <a:xfrm>
-            <a:off x="8138160" y="868680"/>
-            <a:ext cx="1920240" cy="1005840"/>
-          </a:xfrm>
-          <a:prstGeom prst="rect">
-            <a:avLst/>
-          </a:prstGeom>
-          <a:solidFill>
-            <a:srgbClr val="007A7A"/>
-          </a:solidFill>
-          <a:ln>
-            <a:noFill/>
-          </a:ln>
-        </p:spPr>
-        <p:style>
-          <a:lnRef idx="1">
-            <a:schemeClr val="accent1"/>
-          </a:lnRef>
-          <a:fillRef idx="3">
-            <a:schemeClr val="accent1"/>
-          </a:fillRef>
-          <a:effectRef idx="2">
-            <a:schemeClr val="accent1"/>
-          </a:effectRef>
-          <a:fontRef idx="minor">
-            <a:schemeClr val="lt1"/>
-          </a:fontRef>
-        </p:style>
-        <p:txBody>
-          <a:bodyPr rtlCol="0" anchor="ctr"/>
-          <a:lstStyle/>
-          <a:p>
-            <a:pPr algn="ctr"/>
-          </a:p>
-        </p:txBody>
-      </p:sp>
-      <p:sp>
-        <p:nvSpPr>
-          <p:cNvPr id="19" name="TextBox 18"/>
-          <p:cNvSpPr txBox="1"/>
-          <p:nvPr/>
-        </p:nvSpPr>
-        <p:spPr>
-          <a:xfrm>
-            <a:off x="8229600" y="896112"/>
+            <a:off x="6263640" y="822960"/>
             <a:ext cx="1737360" cy="594360"/>
           </a:xfrm>
           <a:prstGeom prst="rect">
@@ -5503,13 +5620,13 @@
       </p:sp>
       <p:sp>
         <p:nvSpPr>
-          <p:cNvPr id="20" name="TextBox 19"/>
+          <p:cNvPr id="21" name="TextBox 20"/>
           <p:cNvSpPr txBox="1"/>
           <p:nvPr/>
         </p:nvSpPr>
         <p:spPr>
           <a:xfrm>
-            <a:off x="8229600" y="1481328"/>
+            <a:off x="6263640" y="1408176"/>
             <a:ext cx="1737360" cy="365760"/>
           </a:xfrm>
           <a:prstGeom prst="rect">
@@ -5527,30 +5644,31 @@
             <a:r>
               <a:rPr sz="900" b="0" i="0">
                 <a:solidFill>
-                  <a:srgbClr val="DDEEEE"/>
+                  <a:srgbClr val="CCEEEE"/>
                 </a:solidFill>
               </a:rPr>
-              <a:t>fonds issus des dons privés</a:t>
-            </a:r>
-          </a:p>
-        </p:txBody>
-      </p:sp>
-      <p:sp>
-        <p:nvSpPr>
-          <p:cNvPr id="21" name="Rectangle 20"/>
+              <a:t>des fonds viennent
+des dons privés</a:t>
+            </a:r>
+          </a:p>
+        </p:txBody>
+      </p:sp>
+      <p:sp>
+        <p:nvSpPr>
+          <p:cNvPr id="22" name="Rectangle 21"/>
           <p:cNvSpPr/>
           <p:nvPr/>
         </p:nvSpPr>
         <p:spPr>
           <a:xfrm>
-            <a:off x="10104120" y="868680"/>
-            <a:ext cx="1920240" cy="1005840"/>
+            <a:off x="8138160" y="804672"/>
+            <a:ext cx="1920240" cy="987552"/>
           </a:xfrm>
           <a:prstGeom prst="rect">
             <a:avLst/>
           </a:prstGeom>
           <a:solidFill>
-            <a:srgbClr val="007A7A"/>
+            <a:srgbClr val="005555"/>
           </a:solidFill>
           <a:ln>
             <a:noFill/>
@@ -5580,13 +5698,13 @@
       </p:sp>
       <p:sp>
         <p:nvSpPr>
-          <p:cNvPr id="22" name="TextBox 21"/>
+          <p:cNvPr id="23" name="TextBox 22"/>
           <p:cNvSpPr txBox="1"/>
           <p:nvPr/>
         </p:nvSpPr>
         <p:spPr>
           <a:xfrm>
-            <a:off x="10195560" y="896112"/>
+            <a:off x="8229600" y="822960"/>
             <a:ext cx="1737360" cy="594360"/>
           </a:xfrm>
           <a:prstGeom prst="rect">
@@ -5607,20 +5725,20 @@
                   <a:srgbClr val="FFFFFF"/>
                 </a:solidFill>
               </a:rPr>
-              <a:t>15 DH/jour</a:t>
-            </a:r>
-          </a:p>
-        </p:txBody>
-      </p:sp>
-      <p:sp>
-        <p:nvSpPr>
-          <p:cNvPr id="23" name="TextBox 22"/>
+              <a:t>3€/j</a:t>
+            </a:r>
+          </a:p>
+        </p:txBody>
+      </p:sp>
+      <p:sp>
+        <p:nvSpPr>
+          <p:cNvPr id="24" name="TextBox 23"/>
           <p:cNvSpPr txBox="1"/>
           <p:nvPr/>
         </p:nvSpPr>
         <p:spPr>
           <a:xfrm>
-            <a:off x="10195560" y="1481328"/>
+            <a:off x="8229600" y="1408176"/>
             <a:ext cx="1737360" cy="365760"/>
           </a:xfrm>
           <a:prstGeom prst="rect">
@@ -5638,24 +5756,68 @@
             <a:r>
               <a:rPr sz="900" b="0" i="0">
                 <a:solidFill>
-                  <a:srgbClr val="DDEEEE"/>
+                  <a:srgbClr val="CCEEEE"/>
                 </a:solidFill>
               </a:rPr>
-              <a:t>coût d'1 kit de survie enfant</a:t>
-            </a:r>
-          </a:p>
-        </p:txBody>
-      </p:sp>
-      <p:sp>
-        <p:nvSpPr>
-          <p:cNvPr id="24" name="TextBox 23"/>
+              <a:t>coût d'1 journée
+d'alimentation enfant</a:t>
+            </a:r>
+          </a:p>
+        </p:txBody>
+      </p:sp>
+      <p:sp>
+        <p:nvSpPr>
+          <p:cNvPr id="25" name="Rectangle 24"/>
+          <p:cNvSpPr/>
+          <p:nvPr/>
+        </p:nvSpPr>
+        <p:spPr>
+          <a:xfrm>
+            <a:off x="10104120" y="804672"/>
+            <a:ext cx="1920240" cy="987552"/>
+          </a:xfrm>
+          <a:prstGeom prst="rect">
+            <a:avLst/>
+          </a:prstGeom>
+          <a:solidFill>
+            <a:srgbClr val="005555"/>
+          </a:solidFill>
+          <a:ln>
+            <a:noFill/>
+          </a:ln>
+        </p:spPr>
+        <p:style>
+          <a:lnRef idx="1">
+            <a:schemeClr val="accent1"/>
+          </a:lnRef>
+          <a:fillRef idx="3">
+            <a:schemeClr val="accent1"/>
+          </a:fillRef>
+          <a:effectRef idx="2">
+            <a:schemeClr val="accent1"/>
+          </a:effectRef>
+          <a:fontRef idx="minor">
+            <a:schemeClr val="lt1"/>
+          </a:fontRef>
+        </p:style>
+        <p:txBody>
+          <a:bodyPr rtlCol="0" anchor="ctr"/>
+          <a:lstStyle/>
+          <a:p>
+            <a:pPr algn="ctr"/>
+          </a:p>
+        </p:txBody>
+      </p:sp>
+      <p:sp>
+        <p:nvSpPr>
+          <p:cNvPr id="26" name="TextBox 25"/>
           <p:cNvSpPr txBox="1"/>
           <p:nvPr/>
         </p:nvSpPr>
         <p:spPr>
           <a:xfrm>
-            <a:off x="274320" y="2011680"/>
-            <a:ext cx="11612880" cy="822960"/>
+            <a:off x="10195560" y="822960"/>
+            <a:ext cx="1737360" cy="594360"/>
           </a:xfrm>
           <a:prstGeom prst="rect">
             <a:avLst/>
@@ -5668,29 +5830,218 @@
           </a:bodyPr>
           <a:lstStyle/>
           <a:p>
+            <a:pPr algn="ctr"/>
+            <a:r>
+              <a:rPr sz="2600" b="1" i="0">
+                <a:solidFill>
+                  <a:srgbClr val="FFFFFF"/>
+                </a:solidFill>
+              </a:rPr>
+              <a:t>82%</a:t>
+            </a:r>
+          </a:p>
+        </p:txBody>
+      </p:sp>
+      <p:sp>
+        <p:nvSpPr>
+          <p:cNvPr id="27" name="TextBox 26"/>
+          <p:cNvSpPr txBox="1"/>
+          <p:nvPr/>
+        </p:nvSpPr>
+        <p:spPr>
+          <a:xfrm>
+            <a:off x="10195560" y="1408176"/>
+            <a:ext cx="1737360" cy="365760"/>
+          </a:xfrm>
+          <a:prstGeom prst="rect">
+            <a:avLst/>
+          </a:prstGeom>
+          <a:noFill/>
+        </p:spPr>
+        <p:txBody>
+          <a:bodyPr wrap="square">
+            <a:spAutoFit/>
+          </a:bodyPr>
+          <a:lstStyle/>
+          <a:p>
+            <a:pPr algn="ctr"/>
+            <a:r>
+              <a:rPr sz="900" b="0" i="0">
+                <a:solidFill>
+                  <a:srgbClr val="CCEEEE"/>
+                </a:solidFill>
+              </a:rPr>
+              <a:t>des dons affectés
+directement aux programmes</a:t>
+            </a:r>
+          </a:p>
+        </p:txBody>
+      </p:sp>
+      <p:sp>
+        <p:nvSpPr>
+          <p:cNvPr id="28" name="TextBox 27"/>
+          <p:cNvSpPr txBox="1"/>
+          <p:nvPr/>
+        </p:nvSpPr>
+        <p:spPr>
+          <a:xfrm>
+            <a:off x="274320" y="1920240"/>
+            <a:ext cx="11640312" cy="320040"/>
+          </a:xfrm>
+          <a:prstGeom prst="rect">
+            <a:avLst/>
+          </a:prstGeom>
+          <a:noFill/>
+        </p:spPr>
+        <p:txBody>
+          <a:bodyPr wrap="square">
+            <a:spAutoFit/>
+          </a:bodyPr>
+          <a:lstStyle/>
+          <a:p>
             <a:pPr algn="l"/>
             <a:r>
-              <a:rPr sz="1200" b="0" i="0">
+              <a:rPr sz="1200" b="1" i="0">
+                <a:solidFill>
+                  <a:srgbClr val="005555"/>
+                </a:solidFill>
+              </a:rPr>
+              <a:t>Ce que vous dites à chaque donateur :</a:t>
+            </a:r>
+          </a:p>
+        </p:txBody>
+      </p:sp>
+      <p:sp>
+        <p:nvSpPr>
+          <p:cNvPr id="29" name="Rectangle 28"/>
+          <p:cNvSpPr/>
+          <p:nvPr/>
+        </p:nvSpPr>
+        <p:spPr>
+          <a:xfrm>
+            <a:off x="274320" y="2286000"/>
+            <a:ext cx="11640312" cy="749808"/>
+          </a:xfrm>
+          <a:prstGeom prst="rect">
+            <a:avLst/>
+          </a:prstGeom>
+          <a:solidFill>
+            <a:srgbClr val="F0F7F7"/>
+          </a:solidFill>
+          <a:ln>
+            <a:noFill/>
+          </a:ln>
+        </p:spPr>
+        <p:style>
+          <a:lnRef idx="1">
+            <a:schemeClr val="accent1"/>
+          </a:lnRef>
+          <a:fillRef idx="3">
+            <a:schemeClr val="accent1"/>
+          </a:fillRef>
+          <a:effectRef idx="2">
+            <a:schemeClr val="accent1"/>
+          </a:effectRef>
+          <a:fontRef idx="minor">
+            <a:schemeClr val="lt1"/>
+          </a:fontRef>
+        </p:style>
+        <p:txBody>
+          <a:bodyPr rtlCol="0" anchor="ctr"/>
+          <a:lstStyle/>
+          <a:p>
+            <a:pPr algn="ctr"/>
+          </a:p>
+        </p:txBody>
+      </p:sp>
+      <p:sp>
+        <p:nvSpPr>
+          <p:cNvPr id="30" name="TextBox 29"/>
+          <p:cNvSpPr txBox="1"/>
+          <p:nvPr/>
+        </p:nvSpPr>
+        <p:spPr>
+          <a:xfrm>
+            <a:off x="411479" y="2359152"/>
+            <a:ext cx="11365992" cy="603503"/>
+          </a:xfrm>
+          <a:prstGeom prst="rect">
+            <a:avLst/>
+          </a:prstGeom>
+          <a:noFill/>
+        </p:spPr>
+        <p:txBody>
+          <a:bodyPr wrap="square">
+            <a:spAutoFit/>
+          </a:bodyPr>
+          <a:lstStyle/>
+          <a:p>
+            <a:pPr algn="l"/>
+            <a:r>
+              <a:rPr sz="1000" b="0" i="0">
                 <a:solidFill>
                   <a:srgbClr val="1A1A1A"/>
                 </a:solidFill>
               </a:rPr>
-              <a:t>Message clé fundraiser : 'Un don de 100 DH/mois = 6 enfants protégés par an'
-Cadre légal : Loi 75-00 sur les associations · Agrément préfectoral · Reçu fiscal</a:t>
-            </a:r>
-          </a:p>
-        </p:txBody>
-      </p:sp>
-      <p:sp>
-        <p:nvSpPr>
-          <p:cNvPr id="25" name="TextBox 24"/>
+              <a:t>« Un don de 10€/mois, c'est 30 centimes par jour — moins qu'un café.
+En 1 an, vous offrez à 6 enfants l'accès à l'eau potable, à la nutrition et aux soins. »</a:t>
+            </a:r>
+          </a:p>
+        </p:txBody>
+      </p:sp>
+      <p:sp>
+        <p:nvSpPr>
+          <p:cNvPr id="31" name="Rectangle 30"/>
+          <p:cNvSpPr/>
+          <p:nvPr/>
+        </p:nvSpPr>
+        <p:spPr>
+          <a:xfrm>
+            <a:off x="274320" y="2286000"/>
+            <a:ext cx="109728" cy="749808"/>
+          </a:xfrm>
+          <a:prstGeom prst="rect">
+            <a:avLst/>
+          </a:prstGeom>
+          <a:solidFill>
+            <a:srgbClr val="FF0000"/>
+          </a:solidFill>
+          <a:ln>
+            <a:noFill/>
+          </a:ln>
+        </p:spPr>
+        <p:style>
+          <a:lnRef idx="1">
+            <a:schemeClr val="accent1"/>
+          </a:lnRef>
+          <a:fillRef idx="3">
+            <a:schemeClr val="accent1"/>
+          </a:fillRef>
+          <a:effectRef idx="2">
+            <a:schemeClr val="accent1"/>
+          </a:effectRef>
+          <a:fontRef idx="minor">
+            <a:schemeClr val="lt1"/>
+          </a:fontRef>
+        </p:style>
+        <p:txBody>
+          <a:bodyPr rtlCol="0" anchor="ctr"/>
+          <a:lstStyle/>
+          <a:p>
+            <a:pPr algn="ctr"/>
+          </a:p>
+        </p:txBody>
+      </p:sp>
+      <p:sp>
+        <p:nvSpPr>
+          <p:cNvPr id="32" name="TextBox 31"/>
           <p:cNvSpPr txBox="1"/>
           <p:nvPr/>
         </p:nvSpPr>
         <p:spPr>
           <a:xfrm>
-            <a:off x="274320" y="2971800"/>
-            <a:ext cx="11612880" cy="274320"/>
+            <a:off x="274320" y="3218688"/>
+            <a:ext cx="11640312" cy="292608"/>
           </a:xfrm>
           <a:prstGeom prst="rect">
             <a:avLst/>
@@ -5707,24 +6058,24 @@
             <a:r>
               <a:rPr sz="1200" b="1" i="0">
                 <a:solidFill>
-                  <a:srgbClr val="005050"/>
+                  <a:srgbClr val="005555"/>
                 </a:solidFill>
               </a:rPr>
-              <a:t>Activité — L'ascenseur de mission (Bloom 3)</a:t>
-            </a:r>
-          </a:p>
-        </p:txBody>
-      </p:sp>
-      <p:sp>
-        <p:nvSpPr>
-          <p:cNvPr id="26" name="Rectangle 25"/>
+              <a:t>Votre activité : L'ascenseur de mission</a:t>
+            </a:r>
+          </a:p>
+        </p:txBody>
+      </p:sp>
+      <p:sp>
+        <p:nvSpPr>
+          <p:cNvPr id="33" name="Rectangle 32"/>
           <p:cNvSpPr/>
           <p:nvPr/>
         </p:nvSpPr>
         <p:spPr>
           <a:xfrm>
-            <a:off x="274320" y="3291840"/>
-            <a:ext cx="2240280" cy="685800"/>
+            <a:off x="274320" y="3584448"/>
+            <a:ext cx="2249424" cy="960120"/>
           </a:xfrm>
           <a:prstGeom prst="rect">
             <a:avLst/>
@@ -5734,7 +6085,7 @@
           </a:solidFill>
           <a:ln w="12700">
             <a:solidFill>
-              <a:srgbClr val="007A7A"/>
+              <a:srgbClr val="008080"/>
             </a:solidFill>
           </a:ln>
         </p:spPr>
@@ -5762,14 +6113,14 @@
       </p:sp>
       <p:sp>
         <p:nvSpPr>
-          <p:cNvPr id="27" name="TextBox 26"/>
+          <p:cNvPr id="34" name="TextBox 33"/>
           <p:cNvSpPr txBox="1"/>
           <p:nvPr/>
         </p:nvSpPr>
         <p:spPr>
           <a:xfrm>
-            <a:off x="365760" y="3337560"/>
-            <a:ext cx="2057400" cy="594360"/>
+            <a:off x="384048" y="3639312"/>
+            <a:ext cx="2029968" cy="841248"/>
           </a:xfrm>
           <a:prstGeom prst="rect">
             <a:avLst/>
@@ -5789,21 +6140,23 @@
                   <a:srgbClr val="1A1A1A"/>
                 </a:solidFill>
               </a:rPr>
-              <a:t>1. Lire seul le brief mission (3 min)</a:t>
-            </a:r>
-          </a:p>
-        </p:txBody>
-      </p:sp>
-      <p:sp>
-        <p:nvSpPr>
-          <p:cNvPr id="28" name="Rectangle 27"/>
+              <a:t>① Lisez seul
+le brief mission
+(3 min)</a:t>
+            </a:r>
+          </a:p>
+        </p:txBody>
+      </p:sp>
+      <p:sp>
+        <p:nvSpPr>
+          <p:cNvPr id="35" name="Rectangle 34"/>
           <p:cNvSpPr/>
           <p:nvPr/>
         </p:nvSpPr>
         <p:spPr>
           <a:xfrm>
-            <a:off x="2560320" y="3291840"/>
-            <a:ext cx="2240280" cy="685800"/>
+            <a:off x="2560320" y="3584448"/>
+            <a:ext cx="2249424" cy="960120"/>
           </a:xfrm>
           <a:prstGeom prst="rect">
             <a:avLst/>
@@ -5813,7 +6166,7 @@
           </a:solidFill>
           <a:ln w="12700">
             <a:solidFill>
-              <a:srgbClr val="007A7A"/>
+              <a:srgbClr val="008080"/>
             </a:solidFill>
           </a:ln>
         </p:spPr>
@@ -5841,14 +6194,14 @@
       </p:sp>
       <p:sp>
         <p:nvSpPr>
-          <p:cNvPr id="29" name="TextBox 28"/>
+          <p:cNvPr id="36" name="TextBox 35"/>
           <p:cNvSpPr txBox="1"/>
           <p:nvPr/>
         </p:nvSpPr>
         <p:spPr>
           <a:xfrm>
-            <a:off x="2651760" y="3337560"/>
-            <a:ext cx="2057400" cy="594360"/>
+            <a:off x="2670048" y="3639312"/>
+            <a:ext cx="2029968" cy="841248"/>
           </a:xfrm>
           <a:prstGeom prst="rect">
             <a:avLst/>
@@ -5868,21 +6221,23 @@
                   <a:srgbClr val="1A1A1A"/>
                 </a:solidFill>
               </a:rPr>
-              <a:t>2. Formuler son pitch 60s (5 min)</a:t>
-            </a:r>
-          </a:p>
-        </p:txBody>
-      </p:sp>
-      <p:sp>
-        <p:nvSpPr>
-          <p:cNvPr id="30" name="Rectangle 29"/>
+              <a:t>② Formulez
+votre pitch 60s
+(5 min)</a:t>
+            </a:r>
+          </a:p>
+        </p:txBody>
+      </p:sp>
+      <p:sp>
+        <p:nvSpPr>
+          <p:cNvPr id="37" name="Rectangle 36"/>
           <p:cNvSpPr/>
           <p:nvPr/>
         </p:nvSpPr>
         <p:spPr>
           <a:xfrm>
-            <a:off x="4846320" y="3291840"/>
-            <a:ext cx="2240280" cy="685800"/>
+            <a:off x="4846320" y="3584448"/>
+            <a:ext cx="2249424" cy="960120"/>
           </a:xfrm>
           <a:prstGeom prst="rect">
             <a:avLst/>
@@ -5892,7 +6247,7 @@
           </a:solidFill>
           <a:ln w="12700">
             <a:solidFill>
-              <a:srgbClr val="007A7A"/>
+              <a:srgbClr val="008080"/>
             </a:solidFill>
           </a:ln>
         </p:spPr>
@@ -5920,14 +6275,14 @@
       </p:sp>
       <p:sp>
         <p:nvSpPr>
-          <p:cNvPr id="31" name="TextBox 30"/>
+          <p:cNvPr id="38" name="TextBox 37"/>
           <p:cNvSpPr txBox="1"/>
           <p:nvPr/>
         </p:nvSpPr>
         <p:spPr>
           <a:xfrm>
-            <a:off x="4937759" y="3337560"/>
-            <a:ext cx="2057400" cy="594360"/>
+            <a:off x="4956048" y="3639312"/>
+            <a:ext cx="2029968" cy="841248"/>
           </a:xfrm>
           <a:prstGeom prst="rect">
             <a:avLst/>
@@ -5947,21 +6302,23 @@
                   <a:srgbClr val="1A1A1A"/>
                 </a:solidFill>
               </a:rPr>
-              <a:t>3. Présenter à son binôme</a:t>
-            </a:r>
-          </a:p>
-        </p:txBody>
-      </p:sp>
-      <p:sp>
-        <p:nvSpPr>
-          <p:cNvPr id="32" name="Rectangle 31"/>
+              <a:t>③ Présentez à
+votre binôme
+(60 sec)</a:t>
+            </a:r>
+          </a:p>
+        </p:txBody>
+      </p:sp>
+      <p:sp>
+        <p:nvSpPr>
+          <p:cNvPr id="39" name="Rectangle 38"/>
           <p:cNvSpPr/>
           <p:nvPr/>
         </p:nvSpPr>
         <p:spPr>
           <a:xfrm>
-            <a:off x="7132320" y="3291840"/>
-            <a:ext cx="2240280" cy="685800"/>
+            <a:off x="7132320" y="3584448"/>
+            <a:ext cx="2249424" cy="960120"/>
           </a:xfrm>
           <a:prstGeom prst="rect">
             <a:avLst/>
@@ -5971,7 +6328,7 @@
           </a:solidFill>
           <a:ln w="12700">
             <a:solidFill>
-              <a:srgbClr val="007A7A"/>
+              <a:srgbClr val="008080"/>
             </a:solidFill>
           </a:ln>
         </p:spPr>
@@ -5999,14 +6356,14 @@
       </p:sp>
       <p:sp>
         <p:nvSpPr>
-          <p:cNvPr id="33" name="TextBox 32"/>
+          <p:cNvPr id="40" name="TextBox 39"/>
           <p:cNvSpPr txBox="1"/>
           <p:nvPr/>
         </p:nvSpPr>
         <p:spPr>
           <a:xfrm>
-            <a:off x="7223759" y="3337560"/>
-            <a:ext cx="2057400" cy="594360"/>
+            <a:off x="7242048" y="3639312"/>
+            <a:ext cx="2029968" cy="841248"/>
           </a:xfrm>
           <a:prstGeom prst="rect">
             <a:avLst/>
@@ -6026,21 +6383,23 @@
                   <a:srgbClr val="1A1A1A"/>
                 </a:solidFill>
               </a:rPr>
-              <a:t>4. Feedback pair : 1 force + 1 conseil</a:t>
-            </a:r>
-          </a:p>
-        </p:txBody>
-      </p:sp>
-      <p:sp>
-        <p:nvSpPr>
-          <p:cNvPr id="34" name="Rectangle 33"/>
+              <a:t>④ Feedback pair :
+1 force + 1 conseil
+(3 min)</a:t>
+            </a:r>
+          </a:p>
+        </p:txBody>
+      </p:sp>
+      <p:sp>
+        <p:nvSpPr>
+          <p:cNvPr id="41" name="Rectangle 40"/>
           <p:cNvSpPr/>
           <p:nvPr/>
         </p:nvSpPr>
         <p:spPr>
           <a:xfrm>
-            <a:off x="9418320" y="3291840"/>
-            <a:ext cx="2240280" cy="685800"/>
+            <a:off x="9418320" y="3584448"/>
+            <a:ext cx="2249424" cy="960120"/>
           </a:xfrm>
           <a:prstGeom prst="rect">
             <a:avLst/>
@@ -6050,7 +6409,7 @@
           </a:solidFill>
           <a:ln w="12700">
             <a:solidFill>
-              <a:srgbClr val="007A7A"/>
+              <a:srgbClr val="008080"/>
             </a:solidFill>
           </a:ln>
         </p:spPr>
@@ -6078,14 +6437,14 @@
       </p:sp>
       <p:sp>
         <p:nvSpPr>
-          <p:cNvPr id="35" name="TextBox 34"/>
+          <p:cNvPr id="42" name="TextBox 41"/>
           <p:cNvSpPr txBox="1"/>
           <p:nvPr/>
         </p:nvSpPr>
         <p:spPr>
           <a:xfrm>
-            <a:off x="9509760" y="3337560"/>
-            <a:ext cx="2057400" cy="594360"/>
+            <a:off x="9528048" y="3639312"/>
+            <a:ext cx="2029968" cy="841248"/>
           </a:xfrm>
           <a:prstGeom prst="rect">
             <a:avLst/>
@@ -6105,21 +6464,66 @@
                   <a:srgbClr val="1A1A1A"/>
                 </a:solidFill>
               </a:rPr>
-              <a:t>5. Améliorer et re-présenter (5 min)</a:t>
-            </a:r>
-          </a:p>
-        </p:txBody>
-      </p:sp>
-      <p:sp>
-        <p:nvSpPr>
-          <p:cNvPr id="36" name="TextBox 35"/>
+              <a:t>⑤ Améliorez et
+représentez
+(5 min)</a:t>
+            </a:r>
+          </a:p>
+        </p:txBody>
+      </p:sp>
+      <p:sp>
+        <p:nvSpPr>
+          <p:cNvPr id="43" name="Rectangle 42"/>
+          <p:cNvSpPr/>
+          <p:nvPr/>
+        </p:nvSpPr>
+        <p:spPr>
+          <a:xfrm>
+            <a:off x="274320" y="4709160"/>
+            <a:ext cx="11640312" cy="384048"/>
+          </a:xfrm>
+          <a:prstGeom prst="rect">
+            <a:avLst/>
+          </a:prstGeom>
+          <a:solidFill>
+            <a:srgbClr val="FF0000"/>
+          </a:solidFill>
+          <a:ln>
+            <a:noFill/>
+          </a:ln>
+        </p:spPr>
+        <p:style>
+          <a:lnRef idx="1">
+            <a:schemeClr val="accent1"/>
+          </a:lnRef>
+          <a:fillRef idx="3">
+            <a:schemeClr val="accent1"/>
+          </a:fillRef>
+          <a:effectRef idx="2">
+            <a:schemeClr val="accent1"/>
+          </a:effectRef>
+          <a:fontRef idx="minor">
+            <a:schemeClr val="lt1"/>
+          </a:fontRef>
+        </p:style>
+        <p:txBody>
+          <a:bodyPr rtlCol="0" anchor="ctr"/>
+          <a:lstStyle/>
+          <a:p>
+            <a:pPr algn="ctr"/>
+          </a:p>
+        </p:txBody>
+      </p:sp>
+      <p:sp>
+        <p:nvSpPr>
+          <p:cNvPr id="44" name="TextBox 43"/>
           <p:cNvSpPr txBox="1"/>
           <p:nvPr/>
         </p:nvSpPr>
         <p:spPr>
           <a:xfrm>
-            <a:off x="274320" y="4114800"/>
-            <a:ext cx="11612880" cy="731520"/>
+            <a:off x="411479" y="4782312"/>
+            <a:ext cx="11365992" cy="237744"/>
           </a:xfrm>
           <a:prstGeom prst="rect">
             <a:avLst/>
@@ -6134,27 +6538,639 @@
           <a:p>
             <a:pPr algn="l"/>
             <a:r>
-              <a:rPr sz="1100" b="0" i="0">
+              <a:rPr sz="1000" b="0" i="0">
+                <a:solidFill>
+                  <a:srgbClr val="FFFFFF"/>
+                </a:solidFill>
+              </a:rPr>
+              <a:t>Éthique fundraiser : Vous représentez l'UNICEF. Badge visible en permanence. Aucune pression sur le donateur. Respect total du refus.</a:t>
+            </a:r>
+          </a:p>
+        </p:txBody>
+      </p:sp>
+    </p:spTree>
+  </p:cSld>
+  <p:clrMapOvr>
+    <a:masterClrMapping/>
+  </p:clrMapOvr>
+</p:sld>
+</file>
+
+<file path=ppt/slides/slide4.xml><?xml version="1.0" encoding="utf-8"?>
+<p:sld xmlns:a="http://schemas.openxmlformats.org/drawingml/2006/main" xmlns:p="http://schemas.openxmlformats.org/presentationml/2006/main" xmlns:r="http://schemas.openxmlformats.org/officeDocument/2006/relationships">
+  <p:cSld>
+    <p:spTree>
+      <p:nvGrpSpPr>
+        <p:cNvPr id="1" name=""/>
+        <p:cNvGrpSpPr/>
+        <p:nvPr/>
+      </p:nvGrpSpPr>
+      <p:grpSpPr/>
+      <p:sp>
+        <p:nvSpPr>
+          <p:cNvPr id="2" name="Rectangle 1"/>
+          <p:cNvSpPr/>
+          <p:nvPr/>
+        </p:nvSpPr>
+        <p:spPr>
+          <a:xfrm>
+            <a:off x="0" y="0"/>
+            <a:ext cx="12188952" cy="6858000"/>
+          </a:xfrm>
+          <a:prstGeom prst="rect">
+            <a:avLst/>
+          </a:prstGeom>
+          <a:solidFill>
+            <a:srgbClr val="F0F7F7"/>
+          </a:solidFill>
+          <a:ln>
+            <a:noFill/>
+          </a:ln>
+        </p:spPr>
+        <p:style>
+          <a:lnRef idx="1">
+            <a:schemeClr val="accent1"/>
+          </a:lnRef>
+          <a:fillRef idx="3">
+            <a:schemeClr val="accent1"/>
+          </a:fillRef>
+          <a:effectRef idx="2">
+            <a:schemeClr val="accent1"/>
+          </a:effectRef>
+          <a:fontRef idx="minor">
+            <a:schemeClr val="lt1"/>
+          </a:fontRef>
+        </p:style>
+        <p:txBody>
+          <a:bodyPr rtlCol="0" anchor="ctr"/>
+          <a:lstStyle/>
+          <a:p>
+            <a:pPr algn="ctr"/>
+          </a:p>
+        </p:txBody>
+      </p:sp>
+      <p:sp>
+        <p:nvSpPr>
+          <p:cNvPr id="3" name="Rectangle 2"/>
+          <p:cNvSpPr/>
+          <p:nvPr/>
+        </p:nvSpPr>
+        <p:spPr>
+          <a:xfrm>
+            <a:off x="0" y="0"/>
+            <a:ext cx="12188952" cy="658368"/>
+          </a:xfrm>
+          <a:prstGeom prst="rect">
+            <a:avLst/>
+          </a:prstGeom>
+          <a:solidFill>
+            <a:srgbClr val="005555"/>
+          </a:solidFill>
+          <a:ln>
+            <a:noFill/>
+          </a:ln>
+        </p:spPr>
+        <p:style>
+          <a:lnRef idx="1">
+            <a:schemeClr val="accent1"/>
+          </a:lnRef>
+          <a:fillRef idx="3">
+            <a:schemeClr val="accent1"/>
+          </a:fillRef>
+          <a:effectRef idx="2">
+            <a:schemeClr val="accent1"/>
+          </a:effectRef>
+          <a:fontRef idx="minor">
+            <a:schemeClr val="lt1"/>
+          </a:fontRef>
+        </p:style>
+        <p:txBody>
+          <a:bodyPr rtlCol="0" anchor="ctr"/>
+          <a:lstStyle/>
+          <a:p>
+            <a:pPr algn="ctr"/>
+          </a:p>
+        </p:txBody>
+      </p:sp>
+      <p:sp>
+        <p:nvSpPr>
+          <p:cNvPr id="4" name="Rectangle 3"/>
+          <p:cNvSpPr/>
+          <p:nvPr/>
+        </p:nvSpPr>
+        <p:spPr>
+          <a:xfrm>
+            <a:off x="0" y="640080"/>
+            <a:ext cx="12188952" cy="54864"/>
+          </a:xfrm>
+          <a:prstGeom prst="rect">
+            <a:avLst/>
+          </a:prstGeom>
+          <a:solidFill>
+            <a:srgbClr val="FF0000"/>
+          </a:solidFill>
+          <a:ln>
+            <a:noFill/>
+          </a:ln>
+        </p:spPr>
+        <p:style>
+          <a:lnRef idx="1">
+            <a:schemeClr val="accent1"/>
+          </a:lnRef>
+          <a:fillRef idx="3">
+            <a:schemeClr val="accent1"/>
+          </a:fillRef>
+          <a:effectRef idx="2">
+            <a:schemeClr val="accent1"/>
+          </a:effectRef>
+          <a:fontRef idx="minor">
+            <a:schemeClr val="lt1"/>
+          </a:fontRef>
+        </p:style>
+        <p:txBody>
+          <a:bodyPr rtlCol="0" anchor="ctr"/>
+          <a:lstStyle/>
+          <a:p>
+            <a:pPr algn="ctr"/>
+          </a:p>
+        </p:txBody>
+      </p:sp>
+      <p:sp>
+        <p:nvSpPr>
+          <p:cNvPr id="5" name="TextBox 4"/>
+          <p:cNvSpPr txBox="1"/>
+          <p:nvPr/>
+        </p:nvSpPr>
+        <p:spPr>
+          <a:xfrm>
+            <a:off x="164592" y="64008"/>
+            <a:ext cx="685800" cy="530352"/>
+          </a:xfrm>
+          <a:prstGeom prst="rect">
+            <a:avLst/>
+          </a:prstGeom>
+          <a:noFill/>
+        </p:spPr>
+        <p:txBody>
+          <a:bodyPr wrap="square">
+            <a:spAutoFit/>
+          </a:bodyPr>
+          <a:lstStyle/>
+          <a:p>
+            <a:pPr algn="l"/>
+            <a:r>
+              <a:rPr sz="2000" b="1" i="0">
+                <a:solidFill>
+                  <a:srgbClr val="FFFFFF"/>
+                </a:solidFill>
+              </a:rPr>
+              <a:t>SHY</a:t>
+            </a:r>
+          </a:p>
+        </p:txBody>
+      </p:sp>
+      <p:sp>
+        <p:nvSpPr>
+          <p:cNvPr id="6" name="Rectangle 5"/>
+          <p:cNvSpPr/>
+          <p:nvPr/>
+        </p:nvSpPr>
+        <p:spPr>
+          <a:xfrm>
+            <a:off x="914400" y="91440"/>
+            <a:ext cx="36576" cy="475488"/>
+          </a:xfrm>
+          <a:prstGeom prst="rect">
+            <a:avLst/>
+          </a:prstGeom>
+          <a:solidFill>
+            <a:srgbClr val="FF0000"/>
+          </a:solidFill>
+          <a:ln>
+            <a:noFill/>
+          </a:ln>
+        </p:spPr>
+        <p:style>
+          <a:lnRef idx="1">
+            <a:schemeClr val="accent1"/>
+          </a:lnRef>
+          <a:fillRef idx="3">
+            <a:schemeClr val="accent1"/>
+          </a:fillRef>
+          <a:effectRef idx="2">
+            <a:schemeClr val="accent1"/>
+          </a:effectRef>
+          <a:fontRef idx="minor">
+            <a:schemeClr val="lt1"/>
+          </a:fontRef>
+        </p:style>
+        <p:txBody>
+          <a:bodyPr rtlCol="0" anchor="ctr"/>
+          <a:lstStyle/>
+          <a:p>
+            <a:pPr algn="ctr"/>
+          </a:p>
+        </p:txBody>
+      </p:sp>
+      <p:sp>
+        <p:nvSpPr>
+          <p:cNvPr id="7" name="TextBox 6"/>
+          <p:cNvSpPr txBox="1"/>
+          <p:nvPr/>
+        </p:nvSpPr>
+        <p:spPr>
+          <a:xfrm>
+            <a:off x="1024128" y="91440"/>
+            <a:ext cx="10881360" cy="475488"/>
+          </a:xfrm>
+          <a:prstGeom prst="rect">
+            <a:avLst/>
+          </a:prstGeom>
+          <a:noFill/>
+        </p:spPr>
+        <p:txBody>
+          <a:bodyPr wrap="square">
+            <a:spAutoFit/>
+          </a:bodyPr>
+          <a:lstStyle/>
+          <a:p>
+            <a:pPr algn="l"/>
+            <a:r>
+              <a:rPr sz="1700" b="1" i="0">
+                <a:solidFill>
+                  <a:srgbClr val="FFFFFF"/>
+                </a:solidFill>
+              </a:rPr>
+              <a:t>Votre Posture de Fundraiser — Ce que le donateur perçoit en 7 secondes</a:t>
+            </a:r>
+          </a:p>
+        </p:txBody>
+      </p:sp>
+      <p:sp>
+        <p:nvSpPr>
+          <p:cNvPr id="8" name="Rectangle 7"/>
+          <p:cNvSpPr/>
+          <p:nvPr/>
+        </p:nvSpPr>
+        <p:spPr>
+          <a:xfrm>
+            <a:off x="0" y="6492240"/>
+            <a:ext cx="12188952" cy="365760"/>
+          </a:xfrm>
+          <a:prstGeom prst="rect">
+            <a:avLst/>
+          </a:prstGeom>
+          <a:solidFill>
+            <a:srgbClr val="005555"/>
+          </a:solidFill>
+          <a:ln>
+            <a:noFill/>
+          </a:ln>
+        </p:spPr>
+        <p:style>
+          <a:lnRef idx="1">
+            <a:schemeClr val="accent1"/>
+          </a:lnRef>
+          <a:fillRef idx="3">
+            <a:schemeClr val="accent1"/>
+          </a:fillRef>
+          <a:effectRef idx="2">
+            <a:schemeClr val="accent1"/>
+          </a:effectRef>
+          <a:fontRef idx="minor">
+            <a:schemeClr val="lt1"/>
+          </a:fontRef>
+        </p:style>
+        <p:txBody>
+          <a:bodyPr rtlCol="0" anchor="ctr"/>
+          <a:lstStyle/>
+          <a:p>
+            <a:pPr algn="ctr"/>
+          </a:p>
+        </p:txBody>
+      </p:sp>
+      <p:sp>
+        <p:nvSpPr>
+          <p:cNvPr id="9" name="TextBox 8"/>
+          <p:cNvSpPr txBox="1"/>
+          <p:nvPr/>
+        </p:nvSpPr>
+        <p:spPr>
+          <a:xfrm>
+            <a:off x="0" y="6519672"/>
+            <a:ext cx="12188952" cy="274320"/>
+          </a:xfrm>
+          <a:prstGeom prst="rect">
+            <a:avLst/>
+          </a:prstGeom>
+          <a:noFill/>
+        </p:spPr>
+        <p:txBody>
+          <a:bodyPr wrap="square">
+            <a:spAutoFit/>
+          </a:bodyPr>
+          <a:lstStyle/>
+          <a:p>
+            <a:pPr algn="ctr"/>
+            <a:r>
+              <a:rPr sz="900" b="0" i="0">
+                <a:solidFill>
+                  <a:srgbClr val="FFFFFF"/>
+                </a:solidFill>
+              </a:rPr>
+              <a:t>SHY-Performance  ·  Formation FIM  ·  V6-01062026SHY-TE</a:t>
+            </a:r>
+          </a:p>
+        </p:txBody>
+      </p:sp>
+      <p:sp>
+        <p:nvSpPr>
+          <p:cNvPr id="10" name="Rectangle 9"/>
+          <p:cNvSpPr/>
+          <p:nvPr/>
+        </p:nvSpPr>
+        <p:spPr>
+          <a:xfrm>
+            <a:off x="274320" y="822960"/>
+            <a:ext cx="5669280" cy="329184"/>
+          </a:xfrm>
+          <a:prstGeom prst="rect">
+            <a:avLst/>
+          </a:prstGeom>
+          <a:solidFill>
+            <a:srgbClr val="008080"/>
+          </a:solidFill>
+          <a:ln>
+            <a:noFill/>
+          </a:ln>
+        </p:spPr>
+        <p:style>
+          <a:lnRef idx="1">
+            <a:schemeClr val="accent1"/>
+          </a:lnRef>
+          <a:fillRef idx="3">
+            <a:schemeClr val="accent1"/>
+          </a:fillRef>
+          <a:effectRef idx="2">
+            <a:schemeClr val="accent1"/>
+          </a:effectRef>
+          <a:fontRef idx="minor">
+            <a:schemeClr val="lt1"/>
+          </a:fontRef>
+        </p:style>
+        <p:txBody>
+          <a:bodyPr rtlCol="0" anchor="ctr"/>
+          <a:lstStyle/>
+          <a:p>
+            <a:pPr algn="ctr"/>
+          </a:p>
+        </p:txBody>
+      </p:sp>
+      <p:sp>
+        <p:nvSpPr>
+          <p:cNvPr id="11" name="TextBox 10"/>
+          <p:cNvSpPr txBox="1"/>
+          <p:nvPr/>
+        </p:nvSpPr>
+        <p:spPr>
+          <a:xfrm>
+            <a:off x="384048" y="868680"/>
+            <a:ext cx="5486400" cy="256032"/>
+          </a:xfrm>
+          <a:prstGeom prst="rect">
+            <a:avLst/>
+          </a:prstGeom>
+          <a:noFill/>
+        </p:spPr>
+        <p:txBody>
+          <a:bodyPr wrap="square">
+            <a:spAutoFit/>
+          </a:bodyPr>
+          <a:lstStyle/>
+          <a:p>
+            <a:pPr algn="l"/>
+            <a:r>
+              <a:rPr sz="1100" b="1" i="0">
+                <a:solidFill>
+                  <a:srgbClr val="FFFFFF"/>
+                </a:solidFill>
+              </a:rPr>
+              <a:t>Ce qui fait une accroche réussie</a:t>
+            </a:r>
+          </a:p>
+        </p:txBody>
+      </p:sp>
+      <p:sp>
+        <p:nvSpPr>
+          <p:cNvPr id="12" name="Rectangle 11"/>
+          <p:cNvSpPr/>
+          <p:nvPr/>
+        </p:nvSpPr>
+        <p:spPr>
+          <a:xfrm>
+            <a:off x="6355080" y="822960"/>
+            <a:ext cx="5669280" cy="329184"/>
+          </a:xfrm>
+          <a:prstGeom prst="rect">
+            <a:avLst/>
+          </a:prstGeom>
+          <a:solidFill>
+            <a:srgbClr val="008080"/>
+          </a:solidFill>
+          <a:ln>
+            <a:noFill/>
+          </a:ln>
+        </p:spPr>
+        <p:style>
+          <a:lnRef idx="1">
+            <a:schemeClr val="accent1"/>
+          </a:lnRef>
+          <a:fillRef idx="3">
+            <a:schemeClr val="accent1"/>
+          </a:fillRef>
+          <a:effectRef idx="2">
+            <a:schemeClr val="accent1"/>
+          </a:effectRef>
+          <a:fontRef idx="minor">
+            <a:schemeClr val="lt1"/>
+          </a:fontRef>
+        </p:style>
+        <p:txBody>
+          <a:bodyPr rtlCol="0" anchor="ctr"/>
+          <a:lstStyle/>
+          <a:p>
+            <a:pPr algn="ctr"/>
+          </a:p>
+        </p:txBody>
+      </p:sp>
+      <p:sp>
+        <p:nvSpPr>
+          <p:cNvPr id="13" name="TextBox 12"/>
+          <p:cNvSpPr txBox="1"/>
+          <p:nvPr/>
+        </p:nvSpPr>
+        <p:spPr>
+          <a:xfrm>
+            <a:off x="6464808" y="868680"/>
+            <a:ext cx="5486400" cy="256032"/>
+          </a:xfrm>
+          <a:prstGeom prst="rect">
+            <a:avLst/>
+          </a:prstGeom>
+          <a:noFill/>
+        </p:spPr>
+        <p:txBody>
+          <a:bodyPr wrap="square">
+            <a:spAutoFit/>
+          </a:bodyPr>
+          <a:lstStyle/>
+          <a:p>
+            <a:pPr algn="l"/>
+            <a:r>
+              <a:rPr sz="1100" b="1" i="0">
+                <a:solidFill>
+                  <a:srgbClr val="FFFFFF"/>
+                </a:solidFill>
+              </a:rPr>
+              <a:t>Ce qui fait fuir le donateur</a:t>
+            </a:r>
+          </a:p>
+        </p:txBody>
+      </p:sp>
+      <p:sp>
+        <p:nvSpPr>
+          <p:cNvPr id="14" name="Rectangle 13"/>
+          <p:cNvSpPr/>
+          <p:nvPr/>
+        </p:nvSpPr>
+        <p:spPr>
+          <a:xfrm>
+            <a:off x="274320" y="1207008"/>
+            <a:ext cx="5669280" cy="402336"/>
+          </a:xfrm>
+          <a:prstGeom prst="rect">
+            <a:avLst/>
+          </a:prstGeom>
+          <a:solidFill>
+            <a:srgbClr val="F0F7F7"/>
+          </a:solidFill>
+          <a:ln w="5080">
+            <a:solidFill>
+              <a:srgbClr val="008080"/>
+            </a:solidFill>
+          </a:ln>
+        </p:spPr>
+        <p:style>
+          <a:lnRef idx="1">
+            <a:schemeClr val="accent1"/>
+          </a:lnRef>
+          <a:fillRef idx="3">
+            <a:schemeClr val="accent1"/>
+          </a:fillRef>
+          <a:effectRef idx="2">
+            <a:schemeClr val="accent1"/>
+          </a:effectRef>
+          <a:fontRef idx="minor">
+            <a:schemeClr val="lt1"/>
+          </a:fontRef>
+        </p:style>
+        <p:txBody>
+          <a:bodyPr rtlCol="0" anchor="ctr"/>
+          <a:lstStyle/>
+          <a:p>
+            <a:pPr algn="ctr"/>
+          </a:p>
+        </p:txBody>
+      </p:sp>
+      <p:sp>
+        <p:nvSpPr>
+          <p:cNvPr id="15" name="TextBox 14"/>
+          <p:cNvSpPr txBox="1"/>
+          <p:nvPr/>
+        </p:nvSpPr>
+        <p:spPr>
+          <a:xfrm>
+            <a:off x="402336" y="1261872"/>
+            <a:ext cx="5440680" cy="329184"/>
+          </a:xfrm>
+          <a:prstGeom prst="rect">
+            <a:avLst/>
+          </a:prstGeom>
+          <a:noFill/>
+        </p:spPr>
+        <p:txBody>
+          <a:bodyPr wrap="square">
+            <a:spAutoFit/>
+          </a:bodyPr>
+          <a:lstStyle/>
+          <a:p>
+            <a:pPr algn="l"/>
+            <a:r>
+              <a:rPr sz="1000" b="0" i="0">
                 <a:solidFill>
                   <a:srgbClr val="1A1A1A"/>
                 </a:solidFill>
               </a:rPr>
-              <a:t>Debate (Bloom 5) : 'Le don mensuel régulier est-il éthique ?'
-2 équipes · 5 min préparation · 10 min débat · 5 min synthèse formateur</a:t>
-            </a:r>
-          </a:p>
-        </p:txBody>
-      </p:sp>
-      <p:sp>
-        <p:nvSpPr>
-          <p:cNvPr id="37" name="TextBox 36"/>
+              <a:t>• Contact visuel direct et souriant — avant de parler</a:t>
+            </a:r>
+          </a:p>
+        </p:txBody>
+      </p:sp>
+      <p:sp>
+        <p:nvSpPr>
+          <p:cNvPr id="16" name="Rectangle 15"/>
+          <p:cNvSpPr/>
+          <p:nvPr/>
+        </p:nvSpPr>
+        <p:spPr>
+          <a:xfrm>
+            <a:off x="274320" y="1627632"/>
+            <a:ext cx="5669280" cy="402336"/>
+          </a:xfrm>
+          <a:prstGeom prst="rect">
+            <a:avLst/>
+          </a:prstGeom>
+          <a:solidFill>
+            <a:srgbClr val="F0F7F7"/>
+          </a:solidFill>
+          <a:ln w="5080">
+            <a:solidFill>
+              <a:srgbClr val="008080"/>
+            </a:solidFill>
+          </a:ln>
+        </p:spPr>
+        <p:style>
+          <a:lnRef idx="1">
+            <a:schemeClr val="accent1"/>
+          </a:lnRef>
+          <a:fillRef idx="3">
+            <a:schemeClr val="accent1"/>
+          </a:fillRef>
+          <a:effectRef idx="2">
+            <a:schemeClr val="accent1"/>
+          </a:effectRef>
+          <a:fontRef idx="minor">
+            <a:schemeClr val="lt1"/>
+          </a:fontRef>
+        </p:style>
+        <p:txBody>
+          <a:bodyPr rtlCol="0" anchor="ctr"/>
+          <a:lstStyle/>
+          <a:p>
+            <a:pPr algn="ctr"/>
+          </a:p>
+        </p:txBody>
+      </p:sp>
+      <p:sp>
+        <p:nvSpPr>
+          <p:cNvPr id="17" name="TextBox 16"/>
           <p:cNvSpPr txBox="1"/>
           <p:nvPr/>
         </p:nvSpPr>
         <p:spPr>
           <a:xfrm>
-            <a:off x="274320" y="4983480"/>
-            <a:ext cx="11612880" cy="320040"/>
+            <a:off x="402336" y="1682496"/>
+            <a:ext cx="5440680" cy="329184"/>
           </a:xfrm>
           <a:prstGeom prst="rect">
             <a:avLst/>
@@ -6169,26 +7185,71 @@
           <a:p>
             <a:pPr algn="l"/>
             <a:r>
-              <a:rPr sz="1100" b="1" i="0">
+              <a:rPr sz="1000" b="0" i="0">
                 <a:solidFill>
-                  <a:srgbClr val="005050"/>
+                  <a:srgbClr val="1A1A1A"/>
                 </a:solidFill>
               </a:rPr>
-              <a:t>🔗 Lien identitaire : cartographie mentale valeurs personnelles ↔ valeurs UNICEF</a:t>
-            </a:r>
-          </a:p>
-        </p:txBody>
-      </p:sp>
-      <p:sp>
-        <p:nvSpPr>
-          <p:cNvPr id="38" name="TextBox 37"/>
+              <a:t>• Corps ouvert, pieds parallèles, bras détendus</a:t>
+            </a:r>
+          </a:p>
+        </p:txBody>
+      </p:sp>
+      <p:sp>
+        <p:nvSpPr>
+          <p:cNvPr id="18" name="Rectangle 17"/>
+          <p:cNvSpPr/>
+          <p:nvPr/>
+        </p:nvSpPr>
+        <p:spPr>
+          <a:xfrm>
+            <a:off x="274320" y="2048256"/>
+            <a:ext cx="5669280" cy="402336"/>
+          </a:xfrm>
+          <a:prstGeom prst="rect">
+            <a:avLst/>
+          </a:prstGeom>
+          <a:solidFill>
+            <a:srgbClr val="F0F7F7"/>
+          </a:solidFill>
+          <a:ln w="5080">
+            <a:solidFill>
+              <a:srgbClr val="008080"/>
+            </a:solidFill>
+          </a:ln>
+        </p:spPr>
+        <p:style>
+          <a:lnRef idx="1">
+            <a:schemeClr val="accent1"/>
+          </a:lnRef>
+          <a:fillRef idx="3">
+            <a:schemeClr val="accent1"/>
+          </a:fillRef>
+          <a:effectRef idx="2">
+            <a:schemeClr val="accent1"/>
+          </a:effectRef>
+          <a:fontRef idx="minor">
+            <a:schemeClr val="lt1"/>
+          </a:fontRef>
+        </p:style>
+        <p:txBody>
+          <a:bodyPr rtlCol="0" anchor="ctr"/>
+          <a:lstStyle/>
+          <a:p>
+            <a:pPr algn="ctr"/>
+          </a:p>
+        </p:txBody>
+      </p:sp>
+      <p:sp>
+        <p:nvSpPr>
+          <p:cNvPr id="19" name="TextBox 18"/>
           <p:cNvSpPr txBox="1"/>
           <p:nvPr/>
         </p:nvSpPr>
         <p:spPr>
           <a:xfrm>
-            <a:off x="0" y="6492240"/>
-            <a:ext cx="12188952" cy="365760"/>
+            <a:off x="402336" y="2103120"/>
+            <a:ext cx="5440680" cy="329184"/>
           </a:xfrm>
           <a:prstGeom prst="rect">
             <a:avLst/>
@@ -6201,14 +7262,644 @@
           </a:bodyPr>
           <a:lstStyle/>
           <a:p>
-            <a:pPr algn="ctr"/>
-            <a:r>
-              <a:rPr sz="800" b="0" i="0">
+            <a:pPr algn="l"/>
+            <a:r>
+              <a:rPr sz="1000" b="0" i="0">
                 <a:solidFill>
-                  <a:srgbClr val="888888"/>
+                  <a:srgbClr val="1A1A1A"/>
                 </a:solidFill>
               </a:rPr>
-              <a:t>SHY-Performance · V6-01062026SHY-TE</a:t>
+              <a:t>• Ton de voix chaleureux et assuré — ni trop fort, ni trop doux</a:t>
+            </a:r>
+          </a:p>
+        </p:txBody>
+      </p:sp>
+      <p:sp>
+        <p:nvSpPr>
+          <p:cNvPr id="20" name="Rectangle 19"/>
+          <p:cNvSpPr/>
+          <p:nvPr/>
+        </p:nvSpPr>
+        <p:spPr>
+          <a:xfrm>
+            <a:off x="274320" y="2468880"/>
+            <a:ext cx="5669280" cy="402336"/>
+          </a:xfrm>
+          <a:prstGeom prst="rect">
+            <a:avLst/>
+          </a:prstGeom>
+          <a:solidFill>
+            <a:srgbClr val="F0F7F7"/>
+          </a:solidFill>
+          <a:ln w="5080">
+            <a:solidFill>
+              <a:srgbClr val="008080"/>
+            </a:solidFill>
+          </a:ln>
+        </p:spPr>
+        <p:style>
+          <a:lnRef idx="1">
+            <a:schemeClr val="accent1"/>
+          </a:lnRef>
+          <a:fillRef idx="3">
+            <a:schemeClr val="accent1"/>
+          </a:fillRef>
+          <a:effectRef idx="2">
+            <a:schemeClr val="accent1"/>
+          </a:effectRef>
+          <a:fontRef idx="minor">
+            <a:schemeClr val="lt1"/>
+          </a:fontRef>
+        </p:style>
+        <p:txBody>
+          <a:bodyPr rtlCol="0" anchor="ctr"/>
+          <a:lstStyle/>
+          <a:p>
+            <a:pPr algn="ctr"/>
+          </a:p>
+        </p:txBody>
+      </p:sp>
+      <p:sp>
+        <p:nvSpPr>
+          <p:cNvPr id="21" name="TextBox 20"/>
+          <p:cNvSpPr txBox="1"/>
+          <p:nvPr/>
+        </p:nvSpPr>
+        <p:spPr>
+          <a:xfrm>
+            <a:off x="402336" y="2523744"/>
+            <a:ext cx="5440680" cy="329184"/>
+          </a:xfrm>
+          <a:prstGeom prst="rect">
+            <a:avLst/>
+          </a:prstGeom>
+          <a:noFill/>
+        </p:spPr>
+        <p:txBody>
+          <a:bodyPr wrap="square">
+            <a:spAutoFit/>
+          </a:bodyPr>
+          <a:lstStyle/>
+          <a:p>
+            <a:pPr algn="l"/>
+            <a:r>
+              <a:rPr sz="1000" b="0" i="0">
+                <a:solidFill>
+                  <a:srgbClr val="1A1A1A"/>
+                </a:solidFill>
+              </a:rPr>
+              <a:t>• Question ouverte qui invite à s'arrêter</a:t>
+            </a:r>
+          </a:p>
+        </p:txBody>
+      </p:sp>
+      <p:sp>
+        <p:nvSpPr>
+          <p:cNvPr id="22" name="Rectangle 21"/>
+          <p:cNvSpPr/>
+          <p:nvPr/>
+        </p:nvSpPr>
+        <p:spPr>
+          <a:xfrm>
+            <a:off x="274320" y="2889504"/>
+            <a:ext cx="5669280" cy="402336"/>
+          </a:xfrm>
+          <a:prstGeom prst="rect">
+            <a:avLst/>
+          </a:prstGeom>
+          <a:solidFill>
+            <a:srgbClr val="F0F7F7"/>
+          </a:solidFill>
+          <a:ln w="5080">
+            <a:solidFill>
+              <a:srgbClr val="008080"/>
+            </a:solidFill>
+          </a:ln>
+        </p:spPr>
+        <p:style>
+          <a:lnRef idx="1">
+            <a:schemeClr val="accent1"/>
+          </a:lnRef>
+          <a:fillRef idx="3">
+            <a:schemeClr val="accent1"/>
+          </a:fillRef>
+          <a:effectRef idx="2">
+            <a:schemeClr val="accent1"/>
+          </a:effectRef>
+          <a:fontRef idx="minor">
+            <a:schemeClr val="lt1"/>
+          </a:fontRef>
+        </p:style>
+        <p:txBody>
+          <a:bodyPr rtlCol="0" anchor="ctr"/>
+          <a:lstStyle/>
+          <a:p>
+            <a:pPr algn="ctr"/>
+          </a:p>
+        </p:txBody>
+      </p:sp>
+      <p:sp>
+        <p:nvSpPr>
+          <p:cNvPr id="23" name="TextBox 22"/>
+          <p:cNvSpPr txBox="1"/>
+          <p:nvPr/>
+        </p:nvSpPr>
+        <p:spPr>
+          <a:xfrm>
+            <a:off x="402336" y="2944368"/>
+            <a:ext cx="5440680" cy="329184"/>
+          </a:xfrm>
+          <a:prstGeom prst="rect">
+            <a:avLst/>
+          </a:prstGeom>
+          <a:noFill/>
+        </p:spPr>
+        <p:txBody>
+          <a:bodyPr wrap="square">
+            <a:spAutoFit/>
+          </a:bodyPr>
+          <a:lstStyle/>
+          <a:p>
+            <a:pPr algn="l"/>
+            <a:r>
+              <a:rPr sz="1000" b="0" i="0">
+                <a:solidFill>
+                  <a:srgbClr val="1A1A1A"/>
+                </a:solidFill>
+              </a:rPr>
+              <a:t>• Énergie positive constante — même après le 10ème refus</a:t>
+            </a:r>
+          </a:p>
+        </p:txBody>
+      </p:sp>
+      <p:sp>
+        <p:nvSpPr>
+          <p:cNvPr id="24" name="Rectangle 23"/>
+          <p:cNvSpPr/>
+          <p:nvPr/>
+        </p:nvSpPr>
+        <p:spPr>
+          <a:xfrm>
+            <a:off x="6355080" y="1207008"/>
+            <a:ext cx="5669280" cy="402336"/>
+          </a:xfrm>
+          <a:prstGeom prst="rect">
+            <a:avLst/>
+          </a:prstGeom>
+          <a:solidFill>
+            <a:srgbClr val="F0F7F7"/>
+          </a:solidFill>
+          <a:ln w="5080">
+            <a:solidFill>
+              <a:srgbClr val="008080"/>
+            </a:solidFill>
+          </a:ln>
+        </p:spPr>
+        <p:style>
+          <a:lnRef idx="1">
+            <a:schemeClr val="accent1"/>
+          </a:lnRef>
+          <a:fillRef idx="3">
+            <a:schemeClr val="accent1"/>
+          </a:fillRef>
+          <a:effectRef idx="2">
+            <a:schemeClr val="accent1"/>
+          </a:effectRef>
+          <a:fontRef idx="minor">
+            <a:schemeClr val="lt1"/>
+          </a:fontRef>
+        </p:style>
+        <p:txBody>
+          <a:bodyPr rtlCol="0" anchor="ctr"/>
+          <a:lstStyle/>
+          <a:p>
+            <a:pPr algn="ctr"/>
+          </a:p>
+        </p:txBody>
+      </p:sp>
+      <p:sp>
+        <p:nvSpPr>
+          <p:cNvPr id="25" name="TextBox 24"/>
+          <p:cNvSpPr txBox="1"/>
+          <p:nvPr/>
+        </p:nvSpPr>
+        <p:spPr>
+          <a:xfrm>
+            <a:off x="6483096" y="1261872"/>
+            <a:ext cx="5440680" cy="329184"/>
+          </a:xfrm>
+          <a:prstGeom prst="rect">
+            <a:avLst/>
+          </a:prstGeom>
+          <a:noFill/>
+        </p:spPr>
+        <p:txBody>
+          <a:bodyPr wrap="square">
+            <a:spAutoFit/>
+          </a:bodyPr>
+          <a:lstStyle/>
+          <a:p>
+            <a:pPr algn="l"/>
+            <a:r>
+              <a:rPr sz="1000" b="0" i="0">
+                <a:solidFill>
+                  <a:srgbClr val="1A1A1A"/>
+                </a:solidFill>
+              </a:rPr>
+              <a:t>• Regard fuyant ou insistant</a:t>
+            </a:r>
+          </a:p>
+        </p:txBody>
+      </p:sp>
+      <p:sp>
+        <p:nvSpPr>
+          <p:cNvPr id="26" name="Rectangle 25"/>
+          <p:cNvSpPr/>
+          <p:nvPr/>
+        </p:nvSpPr>
+        <p:spPr>
+          <a:xfrm>
+            <a:off x="6355080" y="1627632"/>
+            <a:ext cx="5669280" cy="402336"/>
+          </a:xfrm>
+          <a:prstGeom prst="rect">
+            <a:avLst/>
+          </a:prstGeom>
+          <a:solidFill>
+            <a:srgbClr val="F0F7F7"/>
+          </a:solidFill>
+          <a:ln w="5080">
+            <a:solidFill>
+              <a:srgbClr val="008080"/>
+            </a:solidFill>
+          </a:ln>
+        </p:spPr>
+        <p:style>
+          <a:lnRef idx="1">
+            <a:schemeClr val="accent1"/>
+          </a:lnRef>
+          <a:fillRef idx="3">
+            <a:schemeClr val="accent1"/>
+          </a:fillRef>
+          <a:effectRef idx="2">
+            <a:schemeClr val="accent1"/>
+          </a:effectRef>
+          <a:fontRef idx="minor">
+            <a:schemeClr val="lt1"/>
+          </a:fontRef>
+        </p:style>
+        <p:txBody>
+          <a:bodyPr rtlCol="0" anchor="ctr"/>
+          <a:lstStyle/>
+          <a:p>
+            <a:pPr algn="ctr"/>
+          </a:p>
+        </p:txBody>
+      </p:sp>
+      <p:sp>
+        <p:nvSpPr>
+          <p:cNvPr id="27" name="TextBox 26"/>
+          <p:cNvSpPr txBox="1"/>
+          <p:nvPr/>
+        </p:nvSpPr>
+        <p:spPr>
+          <a:xfrm>
+            <a:off x="6483096" y="1682496"/>
+            <a:ext cx="5440680" cy="329184"/>
+          </a:xfrm>
+          <a:prstGeom prst="rect">
+            <a:avLst/>
+          </a:prstGeom>
+          <a:noFill/>
+        </p:spPr>
+        <p:txBody>
+          <a:bodyPr wrap="square">
+            <a:spAutoFit/>
+          </a:bodyPr>
+          <a:lstStyle/>
+          <a:p>
+            <a:pPr algn="l"/>
+            <a:r>
+              <a:rPr sz="1000" b="0" i="0">
+                <a:solidFill>
+                  <a:srgbClr val="1A1A1A"/>
+                </a:solidFill>
+              </a:rPr>
+              <a:t>• Corps en tension, bras croisés ou agités</a:t>
+            </a:r>
+          </a:p>
+        </p:txBody>
+      </p:sp>
+      <p:sp>
+        <p:nvSpPr>
+          <p:cNvPr id="28" name="Rectangle 27"/>
+          <p:cNvSpPr/>
+          <p:nvPr/>
+        </p:nvSpPr>
+        <p:spPr>
+          <a:xfrm>
+            <a:off x="6355080" y="2048256"/>
+            <a:ext cx="5669280" cy="402336"/>
+          </a:xfrm>
+          <a:prstGeom prst="rect">
+            <a:avLst/>
+          </a:prstGeom>
+          <a:solidFill>
+            <a:srgbClr val="F0F7F7"/>
+          </a:solidFill>
+          <a:ln w="5080">
+            <a:solidFill>
+              <a:srgbClr val="008080"/>
+            </a:solidFill>
+          </a:ln>
+        </p:spPr>
+        <p:style>
+          <a:lnRef idx="1">
+            <a:schemeClr val="accent1"/>
+          </a:lnRef>
+          <a:fillRef idx="3">
+            <a:schemeClr val="accent1"/>
+          </a:fillRef>
+          <a:effectRef idx="2">
+            <a:schemeClr val="accent1"/>
+          </a:effectRef>
+          <a:fontRef idx="minor">
+            <a:schemeClr val="lt1"/>
+          </a:fontRef>
+        </p:style>
+        <p:txBody>
+          <a:bodyPr rtlCol="0" anchor="ctr"/>
+          <a:lstStyle/>
+          <a:p>
+            <a:pPr algn="ctr"/>
+          </a:p>
+        </p:txBody>
+      </p:sp>
+      <p:sp>
+        <p:nvSpPr>
+          <p:cNvPr id="29" name="TextBox 28"/>
+          <p:cNvSpPr txBox="1"/>
+          <p:nvPr/>
+        </p:nvSpPr>
+        <p:spPr>
+          <a:xfrm>
+            <a:off x="6483096" y="2103120"/>
+            <a:ext cx="5440680" cy="329184"/>
+          </a:xfrm>
+          <a:prstGeom prst="rect">
+            <a:avLst/>
+          </a:prstGeom>
+          <a:noFill/>
+        </p:spPr>
+        <p:txBody>
+          <a:bodyPr wrap="square">
+            <a:spAutoFit/>
+          </a:bodyPr>
+          <a:lstStyle/>
+          <a:p>
+            <a:pPr algn="l"/>
+            <a:r>
+              <a:rPr sz="1000" b="0" i="0">
+                <a:solidFill>
+                  <a:srgbClr val="1A1A1A"/>
+                </a:solidFill>
+              </a:rPr>
+              <a:t>• Formule d'excuse : 'Excusez-moi de vous déranger…'</a:t>
+            </a:r>
+          </a:p>
+        </p:txBody>
+      </p:sp>
+      <p:sp>
+        <p:nvSpPr>
+          <p:cNvPr id="30" name="Rectangle 29"/>
+          <p:cNvSpPr/>
+          <p:nvPr/>
+        </p:nvSpPr>
+        <p:spPr>
+          <a:xfrm>
+            <a:off x="6355080" y="2468880"/>
+            <a:ext cx="5669280" cy="402336"/>
+          </a:xfrm>
+          <a:prstGeom prst="rect">
+            <a:avLst/>
+          </a:prstGeom>
+          <a:solidFill>
+            <a:srgbClr val="F0F7F7"/>
+          </a:solidFill>
+          <a:ln w="5080">
+            <a:solidFill>
+              <a:srgbClr val="008080"/>
+            </a:solidFill>
+          </a:ln>
+        </p:spPr>
+        <p:style>
+          <a:lnRef idx="1">
+            <a:schemeClr val="accent1"/>
+          </a:lnRef>
+          <a:fillRef idx="3">
+            <a:schemeClr val="accent1"/>
+          </a:fillRef>
+          <a:effectRef idx="2">
+            <a:schemeClr val="accent1"/>
+          </a:effectRef>
+          <a:fontRef idx="minor">
+            <a:schemeClr val="lt1"/>
+          </a:fontRef>
+        </p:style>
+        <p:txBody>
+          <a:bodyPr rtlCol="0" anchor="ctr"/>
+          <a:lstStyle/>
+          <a:p>
+            <a:pPr algn="ctr"/>
+          </a:p>
+        </p:txBody>
+      </p:sp>
+      <p:sp>
+        <p:nvSpPr>
+          <p:cNvPr id="31" name="TextBox 30"/>
+          <p:cNvSpPr txBox="1"/>
+          <p:nvPr/>
+        </p:nvSpPr>
+        <p:spPr>
+          <a:xfrm>
+            <a:off x="6483096" y="2523744"/>
+            <a:ext cx="5440680" cy="329184"/>
+          </a:xfrm>
+          <a:prstGeom prst="rect">
+            <a:avLst/>
+          </a:prstGeom>
+          <a:noFill/>
+        </p:spPr>
+        <p:txBody>
+          <a:bodyPr wrap="square">
+            <a:spAutoFit/>
+          </a:bodyPr>
+          <a:lstStyle/>
+          <a:p>
+            <a:pPr algn="l"/>
+            <a:r>
+              <a:rPr sz="1000" b="0" i="0">
+                <a:solidFill>
+                  <a:srgbClr val="1A1A1A"/>
+                </a:solidFill>
+              </a:rPr>
+              <a:t>• Question fermée : 'Vous avez 2 minutes ?' (réponse attendue : Non)</a:t>
+            </a:r>
+          </a:p>
+        </p:txBody>
+      </p:sp>
+      <p:sp>
+        <p:nvSpPr>
+          <p:cNvPr id="32" name="Rectangle 31"/>
+          <p:cNvSpPr/>
+          <p:nvPr/>
+        </p:nvSpPr>
+        <p:spPr>
+          <a:xfrm>
+            <a:off x="6355080" y="2889504"/>
+            <a:ext cx="5669280" cy="402336"/>
+          </a:xfrm>
+          <a:prstGeom prst="rect">
+            <a:avLst/>
+          </a:prstGeom>
+          <a:solidFill>
+            <a:srgbClr val="F0F7F7"/>
+          </a:solidFill>
+          <a:ln w="5080">
+            <a:solidFill>
+              <a:srgbClr val="008080"/>
+            </a:solidFill>
+          </a:ln>
+        </p:spPr>
+        <p:style>
+          <a:lnRef idx="1">
+            <a:schemeClr val="accent1"/>
+          </a:lnRef>
+          <a:fillRef idx="3">
+            <a:schemeClr val="accent1"/>
+          </a:fillRef>
+          <a:effectRef idx="2">
+            <a:schemeClr val="accent1"/>
+          </a:effectRef>
+          <a:fontRef idx="minor">
+            <a:schemeClr val="lt1"/>
+          </a:fontRef>
+        </p:style>
+        <p:txBody>
+          <a:bodyPr rtlCol="0" anchor="ctr"/>
+          <a:lstStyle/>
+          <a:p>
+            <a:pPr algn="ctr"/>
+          </a:p>
+        </p:txBody>
+      </p:sp>
+      <p:sp>
+        <p:nvSpPr>
+          <p:cNvPr id="33" name="TextBox 32"/>
+          <p:cNvSpPr txBox="1"/>
+          <p:nvPr/>
+        </p:nvSpPr>
+        <p:spPr>
+          <a:xfrm>
+            <a:off x="6483096" y="2944368"/>
+            <a:ext cx="5440680" cy="329184"/>
+          </a:xfrm>
+          <a:prstGeom prst="rect">
+            <a:avLst/>
+          </a:prstGeom>
+          <a:noFill/>
+        </p:spPr>
+        <p:txBody>
+          <a:bodyPr wrap="square">
+            <a:spAutoFit/>
+          </a:bodyPr>
+          <a:lstStyle/>
+          <a:p>
+            <a:pPr algn="l"/>
+            <a:r>
+              <a:rPr sz="1000" b="0" i="0">
+                <a:solidFill>
+                  <a:srgbClr val="1A1A1A"/>
+                </a:solidFill>
+              </a:rPr>
+              <a:t>• Débuter par 'Je vais vous parler d'argent…'</a:t>
+            </a:r>
+          </a:p>
+        </p:txBody>
+      </p:sp>
+      <p:sp>
+        <p:nvSpPr>
+          <p:cNvPr id="34" name="Rectangle 33"/>
+          <p:cNvSpPr/>
+          <p:nvPr/>
+        </p:nvSpPr>
+        <p:spPr>
+          <a:xfrm>
+            <a:off x="274320" y="5486400"/>
+            <a:ext cx="11640312" cy="402336"/>
+          </a:xfrm>
+          <a:prstGeom prst="rect">
+            <a:avLst/>
+          </a:prstGeom>
+          <a:solidFill>
+            <a:srgbClr val="008080"/>
+          </a:solidFill>
+          <a:ln>
+            <a:noFill/>
+          </a:ln>
+        </p:spPr>
+        <p:style>
+          <a:lnRef idx="1">
+            <a:schemeClr val="accent1"/>
+          </a:lnRef>
+          <a:fillRef idx="3">
+            <a:schemeClr val="accent1"/>
+          </a:fillRef>
+          <a:effectRef idx="2">
+            <a:schemeClr val="accent1"/>
+          </a:effectRef>
+          <a:fontRef idx="minor">
+            <a:schemeClr val="lt1"/>
+          </a:fontRef>
+        </p:style>
+        <p:txBody>
+          <a:bodyPr rtlCol="0" anchor="ctr"/>
+          <a:lstStyle/>
+          <a:p>
+            <a:pPr algn="ctr"/>
+          </a:p>
+        </p:txBody>
+      </p:sp>
+      <p:sp>
+        <p:nvSpPr>
+          <p:cNvPr id="35" name="TextBox 34"/>
+          <p:cNvSpPr txBox="1"/>
+          <p:nvPr/>
+        </p:nvSpPr>
+        <p:spPr>
+          <a:xfrm>
+            <a:off x="411479" y="5559552"/>
+            <a:ext cx="11365992" cy="256032"/>
+          </a:xfrm>
+          <a:prstGeom prst="rect">
+            <a:avLst/>
+          </a:prstGeom>
+          <a:noFill/>
+        </p:spPr>
+        <p:txBody>
+          <a:bodyPr wrap="square">
+            <a:spAutoFit/>
+          </a:bodyPr>
+          <a:lstStyle/>
+          <a:p>
+            <a:pPr algn="l"/>
+            <a:r>
+              <a:rPr sz="1000" b="0" i="0">
+                <a:solidFill>
+                  <a:srgbClr val="FFFFFF"/>
+                </a:solidFill>
+              </a:rPr>
+              <a:t>Exercice miroir : Entraînez-vous 2 minutes devant votre téléphone en mode selfie. Regardez votre propre accroche. Qu'est-ce que vous changeriez ?</a:t>
             </a:r>
           </a:p>
         </p:txBody>

</xml_diff>